<commit_message>
Finalizado aba KPIs Executivos
Finalizado callouts, tooltips, medidas, gráficos, formatações, validação dos dados e filtros.
</commit_message>
<xml_diff>
--- a/Background - Fundo Para BI.pptx
+++ b/Background - Fundo Para BI.pptx
@@ -7,13 +7,13 @@
   <p:sldIdLst>
     <p:sldId id="427" r:id="rId5"/>
     <p:sldId id="431" r:id="rId6"/>
-    <p:sldId id="430" r:id="rId7"/>
-    <p:sldId id="428" r:id="rId8"/>
-    <p:sldId id="429" r:id="rId9"/>
-    <p:sldId id="359" r:id="rId10"/>
-    <p:sldId id="379" r:id="rId11"/>
-    <p:sldId id="398" r:id="rId12"/>
-    <p:sldId id="432" r:id="rId13"/>
+    <p:sldId id="434" r:id="rId7"/>
+    <p:sldId id="429" r:id="rId8"/>
+    <p:sldId id="359" r:id="rId9"/>
+    <p:sldId id="379" r:id="rId10"/>
+    <p:sldId id="398" r:id="rId11"/>
+    <p:sldId id="432" r:id="rId12"/>
+    <p:sldId id="433" r:id="rId13"/>
   </p:sldIdLst>
   <p:sldSz cx="51200050" cy="28800425"/>
   <p:notesSz cx="6858000" cy="9144000"/>
@@ -251,7 +251,7 @@
           <a:p>
             <a:fld id="{CF62B505-841C-4C89-B392-8F545B9B6E7F}" type="datetimeFigureOut">
               <a:rPr lang="pt-BR" smtClean="0"/>
-              <a:t>17/04/2026</a:t>
+              <a:t>19/04/2026</a:t>
             </a:fld>
             <a:endParaRPr lang="pt-BR"/>
           </a:p>
@@ -421,7 +421,7 @@
           <a:p>
             <a:fld id="{CF62B505-841C-4C89-B392-8F545B9B6E7F}" type="datetimeFigureOut">
               <a:rPr lang="pt-BR" smtClean="0"/>
-              <a:t>17/04/2026</a:t>
+              <a:t>19/04/2026</a:t>
             </a:fld>
             <a:endParaRPr lang="pt-BR"/>
           </a:p>
@@ -601,7 +601,7 @@
           <a:p>
             <a:fld id="{CF62B505-841C-4C89-B392-8F545B9B6E7F}" type="datetimeFigureOut">
               <a:rPr lang="pt-BR" smtClean="0"/>
-              <a:t>17/04/2026</a:t>
+              <a:t>19/04/2026</a:t>
             </a:fld>
             <a:endParaRPr lang="pt-BR"/>
           </a:p>
@@ -771,7 +771,7 @@
           <a:p>
             <a:fld id="{CF62B505-841C-4C89-B392-8F545B9B6E7F}" type="datetimeFigureOut">
               <a:rPr lang="pt-BR" smtClean="0"/>
-              <a:t>17/04/2026</a:t>
+              <a:t>19/04/2026</a:t>
             </a:fld>
             <a:endParaRPr lang="pt-BR"/>
           </a:p>
@@ -1017,7 +1017,7 @@
           <a:p>
             <a:fld id="{CF62B505-841C-4C89-B392-8F545B9B6E7F}" type="datetimeFigureOut">
               <a:rPr lang="pt-BR" smtClean="0"/>
-              <a:t>17/04/2026</a:t>
+              <a:t>19/04/2026</a:t>
             </a:fld>
             <a:endParaRPr lang="pt-BR"/>
           </a:p>
@@ -1249,7 +1249,7 @@
           <a:p>
             <a:fld id="{CF62B505-841C-4C89-B392-8F545B9B6E7F}" type="datetimeFigureOut">
               <a:rPr lang="pt-BR" smtClean="0"/>
-              <a:t>17/04/2026</a:t>
+              <a:t>19/04/2026</a:t>
             </a:fld>
             <a:endParaRPr lang="pt-BR"/>
           </a:p>
@@ -1616,7 +1616,7 @@
           <a:p>
             <a:fld id="{CF62B505-841C-4C89-B392-8F545B9B6E7F}" type="datetimeFigureOut">
               <a:rPr lang="pt-BR" smtClean="0"/>
-              <a:t>17/04/2026</a:t>
+              <a:t>19/04/2026</a:t>
             </a:fld>
             <a:endParaRPr lang="pt-BR"/>
           </a:p>
@@ -1734,7 +1734,7 @@
           <a:p>
             <a:fld id="{CF62B505-841C-4C89-B392-8F545B9B6E7F}" type="datetimeFigureOut">
               <a:rPr lang="pt-BR" smtClean="0"/>
-              <a:t>17/04/2026</a:t>
+              <a:t>19/04/2026</a:t>
             </a:fld>
             <a:endParaRPr lang="pt-BR"/>
           </a:p>
@@ -1829,7 +1829,7 @@
           <a:p>
             <a:fld id="{CF62B505-841C-4C89-B392-8F545B9B6E7F}" type="datetimeFigureOut">
               <a:rPr lang="pt-BR" smtClean="0"/>
-              <a:t>17/04/2026</a:t>
+              <a:t>19/04/2026</a:t>
             </a:fld>
             <a:endParaRPr lang="pt-BR"/>
           </a:p>
@@ -2106,7 +2106,7 @@
           <a:p>
             <a:fld id="{CF62B505-841C-4C89-B392-8F545B9B6E7F}" type="datetimeFigureOut">
               <a:rPr lang="pt-BR" smtClean="0"/>
-              <a:t>17/04/2026</a:t>
+              <a:t>19/04/2026</a:t>
             </a:fld>
             <a:endParaRPr lang="pt-BR"/>
           </a:p>
@@ -2363,7 +2363,7 @@
           <a:p>
             <a:fld id="{CF62B505-841C-4C89-B392-8F545B9B6E7F}" type="datetimeFigureOut">
               <a:rPr lang="pt-BR" smtClean="0"/>
-              <a:t>17/04/2026</a:t>
+              <a:t>19/04/2026</a:t>
             </a:fld>
             <a:endParaRPr lang="pt-BR"/>
           </a:p>
@@ -2576,7 +2576,7 @@
           <a:p>
             <a:fld id="{CF62B505-841C-4C89-B392-8F545B9B6E7F}" type="datetimeFigureOut">
               <a:rPr lang="pt-BR" smtClean="0"/>
-              <a:t>17/04/2026</a:t>
+              <a:t>19/04/2026</a:t>
             </a:fld>
             <a:endParaRPr lang="pt-BR"/>
           </a:p>
@@ -4155,7 +4155,7 @@
         <p:spPr>
           <a:xfrm>
             <a:off x="17587321" y="9925420"/>
-            <a:ext cx="995739" cy="8770902"/>
+            <a:ext cx="995739" cy="9046812"/>
           </a:xfrm>
           <a:prstGeom prst="roundRect">
             <a:avLst>
@@ -4225,10 +4225,10 @@
       </p:sp>
       <p:pic>
         <p:nvPicPr>
-          <p:cNvPr id="54" name="Imagem 53">
+          <p:cNvPr id="12" name="Imagem 11" descr="Forma, Retângulo&#10;&#10;O conteúdo gerado por IA pode estar incorreto.">
             <a:extLst>
               <a:ext uri="{FF2B5EF4-FFF2-40B4-BE49-F238E27FC236}">
-                <a16:creationId xmlns:a16="http://schemas.microsoft.com/office/drawing/2014/main" id="{24E83163-D18F-E56F-F669-5A4723DE40B3}"/>
+                <a16:creationId xmlns:a16="http://schemas.microsoft.com/office/drawing/2014/main" id="{A609DB09-C8C3-9756-1E6F-B3FF4BF15D74}"/>
               </a:ext>
             </a:extLst>
           </p:cNvPr>
@@ -4238,37 +4238,7 @@
           <p:nvPr/>
         </p:nvPicPr>
         <p:blipFill>
-          <a:blip r:embed="rId2"/>
-          <a:stretch>
-            <a:fillRect/>
-          </a:stretch>
-        </p:blipFill>
-        <p:spPr>
-          <a:xfrm>
-            <a:off x="32775827" y="10067041"/>
-            <a:ext cx="795715" cy="722269"/>
-          </a:xfrm>
-          <a:prstGeom prst="rect">
-            <a:avLst/>
-          </a:prstGeom>
-        </p:spPr>
-      </p:pic>
-      <p:pic>
-        <p:nvPicPr>
-          <p:cNvPr id="12" name="Imagem 11" descr="Forma, Retângulo&#10;&#10;O conteúdo gerado por IA pode estar incorreto.">
-            <a:extLst>
-              <a:ext uri="{FF2B5EF4-FFF2-40B4-BE49-F238E27FC236}">
-                <a16:creationId xmlns:a16="http://schemas.microsoft.com/office/drawing/2014/main" id="{A609DB09-C8C3-9756-1E6F-B3FF4BF15D74}"/>
-              </a:ext>
-            </a:extLst>
-          </p:cNvPr>
-          <p:cNvPicPr>
-            <a:picLocks noChangeAspect="1"/>
-          </p:cNvPicPr>
-          <p:nvPr/>
-        </p:nvPicPr>
-        <p:blipFill>
-          <a:blip r:embed="rId3">
+          <a:blip r:embed="rId2">
             <a:duotone>
               <a:prstClr val="black"/>
               <a:schemeClr val="tx2">
@@ -4310,8 +4280,8 @@
         </p:nvGrpSpPr>
         <p:grpSpPr>
           <a:xfrm>
-            <a:off x="18878189" y="9925420"/>
-            <a:ext cx="13738802" cy="995739"/>
+            <a:off x="18698354" y="9925420"/>
+            <a:ext cx="14918545" cy="995739"/>
             <a:chOff x="18680926" y="9879347"/>
             <a:chExt cx="14002071" cy="1122481"/>
           </a:xfrm>
@@ -4414,1022 +4384,7 @@
           <p:spPr>
             <a:xfrm>
               <a:off x="18891466" y="10005809"/>
-              <a:ext cx="8656648" cy="589818"/>
-            </a:xfrm>
-            <a:prstGeom prst="rect">
-              <a:avLst/>
-            </a:prstGeom>
-            <a:noFill/>
-          </p:spPr>
-          <p:txBody>
-            <a:bodyPr wrap="square" rtlCol="0">
-              <a:spAutoFit/>
-            </a:bodyPr>
-            <a:lstStyle/>
-            <a:p>
-              <a:r>
-                <a:rPr lang="pt-BR" sz="2800" b="1" dirty="0">
-                  <a:solidFill>
-                    <a:schemeClr val="bg1"/>
-                  </a:solidFill>
-                  <a:latin typeface="Din"/>
-                </a:rPr>
-                <a:t>Sales Insights – Visão Executiva</a:t>
-              </a:r>
-            </a:p>
-          </p:txBody>
-        </p:sp>
-        <p:sp>
-          <p:nvSpPr>
-            <p:cNvPr id="8" name="CaixaDeTexto 7">
-              <a:extLst>
-                <a:ext uri="{FF2B5EF4-FFF2-40B4-BE49-F238E27FC236}">
-                  <a16:creationId xmlns:a16="http://schemas.microsoft.com/office/drawing/2014/main" id="{E41C1DBA-F2A3-A81A-025D-DB0CB07A0C2C}"/>
-                </a:ext>
-              </a:extLst>
-            </p:cNvPr>
-            <p:cNvSpPr txBox="1"/>
-            <p:nvPr/>
-          </p:nvSpPr>
-          <p:spPr>
-            <a:xfrm>
-              <a:off x="18891466" y="10581735"/>
-              <a:ext cx="8656648" cy="346952"/>
-            </a:xfrm>
-            <a:prstGeom prst="rect">
-              <a:avLst/>
-            </a:prstGeom>
-            <a:noFill/>
-          </p:spPr>
-          <p:txBody>
-            <a:bodyPr wrap="square" rtlCol="0">
-              <a:spAutoFit/>
-            </a:bodyPr>
-            <a:lstStyle/>
-            <a:p>
-              <a:r>
-                <a:rPr lang="pt-BR" sz="1400" dirty="0">
-                  <a:solidFill>
-                    <a:schemeClr val="bg2">
-                      <a:lumMod val="90000"/>
-                    </a:schemeClr>
-                  </a:solidFill>
-                  <a:latin typeface="Din"/>
-                </a:rPr>
-                <a:t>Bimbo Brasil</a:t>
-              </a:r>
-              <a:r>
-                <a:rPr lang="pt-BR" sz="1400" b="0" i="0" dirty="0">
-                  <a:solidFill>
-                    <a:schemeClr val="bg2">
-                      <a:lumMod val="90000"/>
-                    </a:schemeClr>
-                  </a:solidFill>
-                  <a:effectLst/>
-                  <a:latin typeface="Segoe UI" panose="020B0502040204020203" pitchFamily="34" charset="0"/>
-                </a:rPr>
-                <a:t> · Controladoria DNA</a:t>
-              </a:r>
-              <a:endParaRPr lang="pt-BR" sz="1400" dirty="0">
-                <a:solidFill>
-                  <a:schemeClr val="bg2">
-                    <a:lumMod val="90000"/>
-                  </a:schemeClr>
-                </a:solidFill>
-                <a:latin typeface="Din"/>
-              </a:endParaRPr>
-            </a:p>
-          </p:txBody>
-        </p:sp>
-      </p:grpSp>
-      <p:sp>
-        <p:nvSpPr>
-          <p:cNvPr id="27" name="Retângulo: Cantos Arredondados 26">
-            <a:extLst>
-              <a:ext uri="{FF2B5EF4-FFF2-40B4-BE49-F238E27FC236}">
-                <a16:creationId xmlns:a16="http://schemas.microsoft.com/office/drawing/2014/main" id="{D47BA7C0-4604-0164-6353-C6A63304EA5D}"/>
-              </a:ext>
-            </a:extLst>
-          </p:cNvPr>
-          <p:cNvSpPr/>
-          <p:nvPr/>
-        </p:nvSpPr>
-        <p:spPr>
-          <a:xfrm>
-            <a:off x="18878190" y="12870836"/>
-            <a:ext cx="7145924" cy="2825929"/>
-          </a:xfrm>
-          <a:prstGeom prst="roundRect">
-            <a:avLst>
-              <a:gd name="adj" fmla="val 5412"/>
-            </a:avLst>
-          </a:prstGeom>
-          <a:solidFill>
-            <a:schemeClr val="bg1"/>
-          </a:solidFill>
-          <a:ln>
-            <a:noFill/>
-          </a:ln>
-          <a:effectLst>
-            <a:outerShdw blurRad="50800" dist="38100" dir="5400000" algn="t" rotWithShape="0">
-              <a:srgbClr val="05324B">
-                <a:alpha val="40000"/>
-              </a:srgbClr>
-            </a:outerShdw>
-          </a:effectLst>
-        </p:spPr>
-        <p:style>
-          <a:lnRef idx="2">
-            <a:schemeClr val="accent1">
-              <a:shade val="50000"/>
-            </a:schemeClr>
-          </a:lnRef>
-          <a:fillRef idx="1">
-            <a:schemeClr val="accent1"/>
-          </a:fillRef>
-          <a:effectRef idx="0">
-            <a:schemeClr val="accent1"/>
-          </a:effectRef>
-          <a:fontRef idx="minor">
-            <a:schemeClr val="lt1"/>
-          </a:fontRef>
-        </p:style>
-        <p:txBody>
-          <a:bodyPr rtlCol="0" anchor="ctr"/>
-          <a:lstStyle/>
-          <a:p>
-            <a:pPr algn="ctr"/>
-            <a:endParaRPr lang="pt-BR" sz="2400" dirty="0">
-              <a:solidFill>
-                <a:prstClr val="white"/>
-              </a:solidFill>
-              <a:latin typeface="Calibri" panose="020F0502020204030204"/>
-            </a:endParaRPr>
-          </a:p>
-        </p:txBody>
-      </p:sp>
-      <p:sp>
-        <p:nvSpPr>
-          <p:cNvPr id="49" name="Retângulo: Cantos Arredondados 48">
-            <a:extLst>
-              <a:ext uri="{FF2B5EF4-FFF2-40B4-BE49-F238E27FC236}">
-                <a16:creationId xmlns:a16="http://schemas.microsoft.com/office/drawing/2014/main" id="{A8FBDF4F-5A37-7087-4390-6E3BFC938F7A}"/>
-              </a:ext>
-            </a:extLst>
-          </p:cNvPr>
-          <p:cNvSpPr/>
-          <p:nvPr/>
-        </p:nvSpPr>
-        <p:spPr>
-          <a:xfrm>
-            <a:off x="26304730" y="12870836"/>
-            <a:ext cx="7145924" cy="2825929"/>
-          </a:xfrm>
-          <a:prstGeom prst="roundRect">
-            <a:avLst>
-              <a:gd name="adj" fmla="val 5412"/>
-            </a:avLst>
-          </a:prstGeom>
-          <a:solidFill>
-            <a:schemeClr val="bg1"/>
-          </a:solidFill>
-          <a:ln>
-            <a:noFill/>
-          </a:ln>
-          <a:effectLst>
-            <a:outerShdw blurRad="50800" dist="38100" dir="5400000" algn="t" rotWithShape="0">
-              <a:srgbClr val="05324B">
-                <a:alpha val="40000"/>
-              </a:srgbClr>
-            </a:outerShdw>
-          </a:effectLst>
-        </p:spPr>
-        <p:style>
-          <a:lnRef idx="2">
-            <a:schemeClr val="accent1">
-              <a:shade val="50000"/>
-            </a:schemeClr>
-          </a:lnRef>
-          <a:fillRef idx="1">
-            <a:schemeClr val="accent1"/>
-          </a:fillRef>
-          <a:effectRef idx="0">
-            <a:schemeClr val="accent1"/>
-          </a:effectRef>
-          <a:fontRef idx="minor">
-            <a:schemeClr val="lt1"/>
-          </a:fontRef>
-        </p:style>
-        <p:txBody>
-          <a:bodyPr rtlCol="0" anchor="ctr"/>
-          <a:lstStyle/>
-          <a:p>
-            <a:pPr algn="ctr"/>
-            <a:endParaRPr lang="pt-BR" sz="2400" dirty="0">
-              <a:solidFill>
-                <a:prstClr val="white"/>
-              </a:solidFill>
-              <a:latin typeface="Calibri" panose="020F0502020204030204"/>
-            </a:endParaRPr>
-          </a:p>
-        </p:txBody>
-      </p:sp>
-      <p:sp>
-        <p:nvSpPr>
-          <p:cNvPr id="50" name="Retângulo: Cantos Arredondados 49">
-            <a:extLst>
-              <a:ext uri="{FF2B5EF4-FFF2-40B4-BE49-F238E27FC236}">
-                <a16:creationId xmlns:a16="http://schemas.microsoft.com/office/drawing/2014/main" id="{E643718C-798E-68B6-7225-98DB47901B9C}"/>
-              </a:ext>
-            </a:extLst>
-          </p:cNvPr>
-          <p:cNvSpPr/>
-          <p:nvPr/>
-        </p:nvSpPr>
-        <p:spPr>
-          <a:xfrm>
-            <a:off x="18878190" y="15870393"/>
-            <a:ext cx="7145924" cy="2825929"/>
-          </a:xfrm>
-          <a:prstGeom prst="roundRect">
-            <a:avLst>
-              <a:gd name="adj" fmla="val 5412"/>
-            </a:avLst>
-          </a:prstGeom>
-          <a:solidFill>
-            <a:schemeClr val="bg1"/>
-          </a:solidFill>
-          <a:ln>
-            <a:noFill/>
-          </a:ln>
-          <a:effectLst>
-            <a:outerShdw blurRad="50800" dist="38100" dir="5400000" algn="t" rotWithShape="0">
-              <a:srgbClr val="05324B">
-                <a:alpha val="40000"/>
-              </a:srgbClr>
-            </a:outerShdw>
-          </a:effectLst>
-        </p:spPr>
-        <p:style>
-          <a:lnRef idx="2">
-            <a:schemeClr val="accent1">
-              <a:shade val="50000"/>
-            </a:schemeClr>
-          </a:lnRef>
-          <a:fillRef idx="1">
-            <a:schemeClr val="accent1"/>
-          </a:fillRef>
-          <a:effectRef idx="0">
-            <a:schemeClr val="accent1"/>
-          </a:effectRef>
-          <a:fontRef idx="minor">
-            <a:schemeClr val="lt1"/>
-          </a:fontRef>
-        </p:style>
-        <p:txBody>
-          <a:bodyPr rtlCol="0" anchor="ctr"/>
-          <a:lstStyle/>
-          <a:p>
-            <a:pPr algn="ctr"/>
-            <a:endParaRPr lang="pt-BR" sz="2400" dirty="0">
-              <a:solidFill>
-                <a:prstClr val="white"/>
-              </a:solidFill>
-              <a:latin typeface="Calibri" panose="020F0502020204030204"/>
-            </a:endParaRPr>
-          </a:p>
-        </p:txBody>
-      </p:sp>
-      <p:sp>
-        <p:nvSpPr>
-          <p:cNvPr id="51" name="Retângulo: Cantos Arredondados 50">
-            <a:extLst>
-              <a:ext uri="{FF2B5EF4-FFF2-40B4-BE49-F238E27FC236}">
-                <a16:creationId xmlns:a16="http://schemas.microsoft.com/office/drawing/2014/main" id="{D5AB2F79-9BBC-92E1-23EE-1ED04E324B9E}"/>
-              </a:ext>
-            </a:extLst>
-          </p:cNvPr>
-          <p:cNvSpPr/>
-          <p:nvPr/>
-        </p:nvSpPr>
-        <p:spPr>
-          <a:xfrm>
-            <a:off x="26304730" y="15870393"/>
-            <a:ext cx="7145924" cy="2825929"/>
-          </a:xfrm>
-          <a:prstGeom prst="roundRect">
-            <a:avLst>
-              <a:gd name="adj" fmla="val 5412"/>
-            </a:avLst>
-          </a:prstGeom>
-          <a:solidFill>
-            <a:schemeClr val="bg1"/>
-          </a:solidFill>
-          <a:ln>
-            <a:noFill/>
-          </a:ln>
-          <a:effectLst>
-            <a:outerShdw blurRad="50800" dist="38100" dir="5400000" algn="t" rotWithShape="0">
-              <a:srgbClr val="05324B">
-                <a:alpha val="40000"/>
-              </a:srgbClr>
-            </a:outerShdw>
-          </a:effectLst>
-        </p:spPr>
-        <p:style>
-          <a:lnRef idx="2">
-            <a:schemeClr val="accent1">
-              <a:shade val="50000"/>
-            </a:schemeClr>
-          </a:lnRef>
-          <a:fillRef idx="1">
-            <a:schemeClr val="accent1"/>
-          </a:fillRef>
-          <a:effectRef idx="0">
-            <a:schemeClr val="accent1"/>
-          </a:effectRef>
-          <a:fontRef idx="minor">
-            <a:schemeClr val="lt1"/>
-          </a:fontRef>
-        </p:style>
-        <p:txBody>
-          <a:bodyPr rtlCol="0" anchor="ctr"/>
-          <a:lstStyle/>
-          <a:p>
-            <a:pPr algn="ctr"/>
-            <a:endParaRPr lang="pt-BR" sz="2400" dirty="0">
-              <a:solidFill>
-                <a:prstClr val="white"/>
-              </a:solidFill>
-              <a:latin typeface="Calibri" panose="020F0502020204030204"/>
-            </a:endParaRPr>
-          </a:p>
-        </p:txBody>
-      </p:sp>
-      <p:sp>
-        <p:nvSpPr>
-          <p:cNvPr id="62" name="Retângulo: Cantos Arredondados 61">
-            <a:extLst>
-              <a:ext uri="{FF2B5EF4-FFF2-40B4-BE49-F238E27FC236}">
-                <a16:creationId xmlns:a16="http://schemas.microsoft.com/office/drawing/2014/main" id="{54CE131E-9AA6-5376-F90A-BA4B311AFBBF}"/>
-              </a:ext>
-            </a:extLst>
-          </p:cNvPr>
-          <p:cNvSpPr/>
-          <p:nvPr/>
-        </p:nvSpPr>
-        <p:spPr>
-          <a:xfrm>
-            <a:off x="21877825" y="11075213"/>
-            <a:ext cx="2573924" cy="1602422"/>
-          </a:xfrm>
-          <a:prstGeom prst="roundRect">
-            <a:avLst/>
-          </a:prstGeom>
-          <a:solidFill>
-            <a:schemeClr val="bg1"/>
-          </a:solidFill>
-          <a:ln>
-            <a:noFill/>
-          </a:ln>
-          <a:effectLst>
-            <a:outerShdw blurRad="50800" dist="38100" dir="5400000" algn="t" rotWithShape="0">
-              <a:srgbClr val="05324B">
-                <a:alpha val="40000"/>
-              </a:srgbClr>
-            </a:outerShdw>
-          </a:effectLst>
-        </p:spPr>
-        <p:style>
-          <a:lnRef idx="2">
-            <a:schemeClr val="accent1">
-              <a:shade val="50000"/>
-            </a:schemeClr>
-          </a:lnRef>
-          <a:fillRef idx="1">
-            <a:schemeClr val="accent1"/>
-          </a:fillRef>
-          <a:effectRef idx="0">
-            <a:schemeClr val="accent1"/>
-          </a:effectRef>
-          <a:fontRef idx="minor">
-            <a:schemeClr val="lt1"/>
-          </a:fontRef>
-        </p:style>
-        <p:txBody>
-          <a:bodyPr rtlCol="0" anchor="ctr"/>
-          <a:lstStyle/>
-          <a:p>
-            <a:pPr algn="ctr"/>
-            <a:endParaRPr lang="pt-BR" sz="2400">
-              <a:solidFill>
-                <a:prstClr val="white"/>
-              </a:solidFill>
-              <a:latin typeface="Calibri" panose="020F0502020204030204"/>
-            </a:endParaRPr>
-          </a:p>
-        </p:txBody>
-      </p:sp>
-      <p:sp>
-        <p:nvSpPr>
-          <p:cNvPr id="63" name="Retângulo: Cantos Arredondados 62">
-            <a:extLst>
-              <a:ext uri="{FF2B5EF4-FFF2-40B4-BE49-F238E27FC236}">
-                <a16:creationId xmlns:a16="http://schemas.microsoft.com/office/drawing/2014/main" id="{44F082B5-0DA2-56FE-C6D7-56119385B762}"/>
-              </a:ext>
-            </a:extLst>
-          </p:cNvPr>
-          <p:cNvSpPr/>
-          <p:nvPr/>
-        </p:nvSpPr>
-        <p:spPr>
-          <a:xfrm>
-            <a:off x="24877460" y="11075213"/>
-            <a:ext cx="2573924" cy="1602422"/>
-          </a:xfrm>
-          <a:prstGeom prst="roundRect">
-            <a:avLst/>
-          </a:prstGeom>
-          <a:solidFill>
-            <a:schemeClr val="bg1"/>
-          </a:solidFill>
-          <a:ln>
-            <a:noFill/>
-          </a:ln>
-          <a:effectLst>
-            <a:outerShdw blurRad="50800" dist="38100" dir="5400000" algn="t" rotWithShape="0">
-              <a:srgbClr val="05324B">
-                <a:alpha val="40000"/>
-              </a:srgbClr>
-            </a:outerShdw>
-          </a:effectLst>
-        </p:spPr>
-        <p:style>
-          <a:lnRef idx="2">
-            <a:schemeClr val="accent1">
-              <a:shade val="50000"/>
-            </a:schemeClr>
-          </a:lnRef>
-          <a:fillRef idx="1">
-            <a:schemeClr val="accent1"/>
-          </a:fillRef>
-          <a:effectRef idx="0">
-            <a:schemeClr val="accent1"/>
-          </a:effectRef>
-          <a:fontRef idx="minor">
-            <a:schemeClr val="lt1"/>
-          </a:fontRef>
-        </p:style>
-        <p:txBody>
-          <a:bodyPr rtlCol="0" anchor="ctr"/>
-          <a:lstStyle/>
-          <a:p>
-            <a:pPr algn="ctr"/>
-            <a:endParaRPr lang="pt-BR" sz="2400">
-              <a:solidFill>
-                <a:prstClr val="white"/>
-              </a:solidFill>
-              <a:latin typeface="Calibri" panose="020F0502020204030204"/>
-            </a:endParaRPr>
-          </a:p>
-        </p:txBody>
-      </p:sp>
-      <p:sp>
-        <p:nvSpPr>
-          <p:cNvPr id="64" name="Retângulo: Cantos Arredondados 63">
-            <a:extLst>
-              <a:ext uri="{FF2B5EF4-FFF2-40B4-BE49-F238E27FC236}">
-                <a16:creationId xmlns:a16="http://schemas.microsoft.com/office/drawing/2014/main" id="{86FCBD4A-570D-099B-EDF6-19810CBAF97E}"/>
-              </a:ext>
-            </a:extLst>
-          </p:cNvPr>
-          <p:cNvSpPr/>
-          <p:nvPr/>
-        </p:nvSpPr>
-        <p:spPr>
-          <a:xfrm>
-            <a:off x="27877095" y="11075213"/>
-            <a:ext cx="2573924" cy="1602422"/>
-          </a:xfrm>
-          <a:prstGeom prst="roundRect">
-            <a:avLst/>
-          </a:prstGeom>
-          <a:solidFill>
-            <a:schemeClr val="bg1"/>
-          </a:solidFill>
-          <a:ln>
-            <a:noFill/>
-          </a:ln>
-          <a:effectLst>
-            <a:outerShdw blurRad="50800" dist="38100" dir="5400000" algn="t" rotWithShape="0">
-              <a:srgbClr val="05324B">
-                <a:alpha val="40000"/>
-              </a:srgbClr>
-            </a:outerShdw>
-          </a:effectLst>
-        </p:spPr>
-        <p:style>
-          <a:lnRef idx="2">
-            <a:schemeClr val="accent1">
-              <a:shade val="50000"/>
-            </a:schemeClr>
-          </a:lnRef>
-          <a:fillRef idx="1">
-            <a:schemeClr val="accent1"/>
-          </a:fillRef>
-          <a:effectRef idx="0">
-            <a:schemeClr val="accent1"/>
-          </a:effectRef>
-          <a:fontRef idx="minor">
-            <a:schemeClr val="lt1"/>
-          </a:fontRef>
-        </p:style>
-        <p:txBody>
-          <a:bodyPr rtlCol="0" anchor="ctr"/>
-          <a:lstStyle/>
-          <a:p>
-            <a:pPr algn="ctr"/>
-            <a:endParaRPr lang="pt-BR" sz="2400">
-              <a:solidFill>
-                <a:prstClr val="white"/>
-              </a:solidFill>
-              <a:latin typeface="Calibri" panose="020F0502020204030204"/>
-            </a:endParaRPr>
-          </a:p>
-        </p:txBody>
-      </p:sp>
-      <p:pic>
-        <p:nvPicPr>
-          <p:cNvPr id="66" name="Imagem 65" descr="Ícone&#10;&#10;O conteúdo gerado por IA pode estar incorreto.">
-            <a:extLst>
-              <a:ext uri="{FF2B5EF4-FFF2-40B4-BE49-F238E27FC236}">
-                <a16:creationId xmlns:a16="http://schemas.microsoft.com/office/drawing/2014/main" id="{83ABFDCB-63D0-18AA-5162-9C42B90F83FE}"/>
-              </a:ext>
-            </a:extLst>
-          </p:cNvPr>
-          <p:cNvPicPr>
-            <a:picLocks noChangeAspect="1"/>
-          </p:cNvPicPr>
-          <p:nvPr/>
-        </p:nvPicPr>
-        <p:blipFill>
-          <a:blip r:embed="rId4">
-            <a:duotone>
-              <a:prstClr val="black"/>
-              <a:schemeClr val="tx2">
-                <a:tint val="45000"/>
-                <a:satMod val="400000"/>
-              </a:schemeClr>
-            </a:duotone>
-            <a:extLst>
-              <a:ext uri="{28A0092B-C50C-407E-A947-70E740481C1C}">
-                <a14:useLocalDpi xmlns:a14="http://schemas.microsoft.com/office/drawing/2010/main" val="0"/>
-              </a:ext>
-            </a:extLst>
-          </a:blip>
-          <a:stretch>
-            <a:fillRect/>
-          </a:stretch>
-        </p:blipFill>
-        <p:spPr>
-          <a:xfrm>
-            <a:off x="17820139" y="13678050"/>
-            <a:ext cx="532661" cy="532661"/>
-          </a:xfrm>
-          <a:prstGeom prst="rect">
-            <a:avLst/>
-          </a:prstGeom>
-        </p:spPr>
-      </p:pic>
-      <p:pic>
-        <p:nvPicPr>
-          <p:cNvPr id="67" name="Imagem 66" descr="Ícone&#10;&#10;O conteúdo gerado por IA pode estar incorreto.">
-            <a:extLst>
-              <a:ext uri="{FF2B5EF4-FFF2-40B4-BE49-F238E27FC236}">
-                <a16:creationId xmlns:a16="http://schemas.microsoft.com/office/drawing/2014/main" id="{89E6F8FC-7B3D-CA4C-9D48-5EF723113782}"/>
-              </a:ext>
-            </a:extLst>
-          </p:cNvPr>
-          <p:cNvPicPr>
-            <a:picLocks noChangeAspect="1"/>
-          </p:cNvPicPr>
-          <p:nvPr/>
-        </p:nvPicPr>
-        <p:blipFill>
-          <a:blip r:embed="rId5">
-            <a:extLst>
-              <a:ext uri="{28A0092B-C50C-407E-A947-70E740481C1C}">
-                <a14:useLocalDpi xmlns:a14="http://schemas.microsoft.com/office/drawing/2010/main" val="0"/>
-              </a:ext>
-            </a:extLst>
-          </a:blip>
-          <a:stretch>
-            <a:fillRect/>
-          </a:stretch>
-        </p:blipFill>
-        <p:spPr>
-          <a:xfrm>
-            <a:off x="17820140" y="11586643"/>
-            <a:ext cx="532661" cy="532661"/>
-          </a:xfrm>
-          <a:prstGeom prst="rect">
-            <a:avLst/>
-          </a:prstGeom>
-          <a:effectLst>
-            <a:glow rad="63500">
-              <a:schemeClr val="accent1">
-                <a:satMod val="175000"/>
-                <a:alpha val="40000"/>
-              </a:schemeClr>
-            </a:glow>
-          </a:effectLst>
-        </p:spPr>
-      </p:pic>
-      <p:pic>
-        <p:nvPicPr>
-          <p:cNvPr id="68" name="Imagem 67" descr="Ícone&#10;&#10;O conteúdo gerado por IA pode estar incorreto.">
-            <a:extLst>
-              <a:ext uri="{FF2B5EF4-FFF2-40B4-BE49-F238E27FC236}">
-                <a16:creationId xmlns:a16="http://schemas.microsoft.com/office/drawing/2014/main" id="{9B121555-8D51-DA4C-E218-3EE23B5F3592}"/>
-              </a:ext>
-            </a:extLst>
-          </p:cNvPr>
-          <p:cNvPicPr>
-            <a:picLocks noChangeAspect="1"/>
-          </p:cNvPicPr>
-          <p:nvPr/>
-        </p:nvPicPr>
-        <p:blipFill>
-          <a:blip r:embed="rId6">
-            <a:duotone>
-              <a:prstClr val="black"/>
-              <a:schemeClr val="tx2">
-                <a:tint val="45000"/>
-                <a:satMod val="400000"/>
-              </a:schemeClr>
-            </a:duotone>
-            <a:extLst>
-              <a:ext uri="{28A0092B-C50C-407E-A947-70E740481C1C}">
-                <a14:useLocalDpi xmlns:a14="http://schemas.microsoft.com/office/drawing/2010/main" val="0"/>
-              </a:ext>
-            </a:extLst>
-          </a:blip>
-          <a:stretch>
-            <a:fillRect/>
-          </a:stretch>
-        </p:blipFill>
-        <p:spPr>
-          <a:xfrm>
-            <a:off x="17820140" y="12646861"/>
-            <a:ext cx="532660" cy="532660"/>
-          </a:xfrm>
-          <a:prstGeom prst="rect">
-            <a:avLst/>
-          </a:prstGeom>
-        </p:spPr>
-      </p:pic>
-    </p:spTree>
-    <p:extLst>
-      <p:ext uri="{BB962C8B-B14F-4D97-AF65-F5344CB8AC3E}">
-        <p14:creationId xmlns:p14="http://schemas.microsoft.com/office/powerpoint/2010/main" val="1800183230"/>
-      </p:ext>
-    </p:extLst>
-  </p:cSld>
-  <p:clrMapOvr>
-    <a:masterClrMapping/>
-  </p:clrMapOvr>
-</p:sld>
-</file>
-
-<file path=ppt/slides/slide3.xml><?xml version="1.0" encoding="utf-8"?>
-<p:sld xmlns:a="http://schemas.openxmlformats.org/drawingml/2006/main" xmlns:r="http://schemas.openxmlformats.org/officeDocument/2006/relationships" xmlns:p="http://schemas.openxmlformats.org/presentationml/2006/main">
-  <p:cSld>
-    <p:spTree>
-      <p:nvGrpSpPr>
-        <p:cNvPr id="1" name="">
-          <a:extLst>
-            <a:ext uri="{FF2B5EF4-FFF2-40B4-BE49-F238E27FC236}">
-              <a16:creationId xmlns:a16="http://schemas.microsoft.com/office/drawing/2014/main" id="{AAF82C59-4899-035E-3BA8-BF64DD6DACC8}"/>
-            </a:ext>
-          </a:extLst>
-        </p:cNvPr>
-        <p:cNvGrpSpPr/>
-        <p:nvPr/>
-      </p:nvGrpSpPr>
-      <p:grpSpPr>
-        <a:xfrm>
-          <a:off x="0" y="0"/>
-          <a:ext cx="0" cy="0"/>
-          <a:chOff x="0" y="0"/>
-          <a:chExt cx="0" cy="0"/>
-        </a:xfrm>
-      </p:grpSpPr>
-      <p:sp>
-        <p:nvSpPr>
-          <p:cNvPr id="37" name="Retângulo: Cantos Arredondados 36">
-            <a:extLst>
-              <a:ext uri="{FF2B5EF4-FFF2-40B4-BE49-F238E27FC236}">
-                <a16:creationId xmlns:a16="http://schemas.microsoft.com/office/drawing/2014/main" id="{2FC03085-CC76-C555-725A-A7677B79034E}"/>
-              </a:ext>
-            </a:extLst>
-          </p:cNvPr>
-          <p:cNvSpPr/>
-          <p:nvPr/>
-        </p:nvSpPr>
-        <p:spPr>
-          <a:xfrm>
-            <a:off x="17472027" y="9852690"/>
-            <a:ext cx="16255996" cy="9119542"/>
-          </a:xfrm>
-          <a:prstGeom prst="roundRect">
-            <a:avLst>
-              <a:gd name="adj" fmla="val 3334"/>
-            </a:avLst>
-          </a:prstGeom>
-          <a:solidFill>
-            <a:srgbClr val="F5F7F9"/>
-          </a:solidFill>
-          <a:ln>
-            <a:solidFill>
-              <a:srgbClr val="F5F7F9"/>
-            </a:solidFill>
-          </a:ln>
-        </p:spPr>
-        <p:style>
-          <a:lnRef idx="2">
-            <a:schemeClr val="accent1">
-              <a:shade val="50000"/>
-            </a:schemeClr>
-          </a:lnRef>
-          <a:fillRef idx="1">
-            <a:schemeClr val="accent1"/>
-          </a:fillRef>
-          <a:effectRef idx="0">
-            <a:schemeClr val="accent1"/>
-          </a:effectRef>
-          <a:fontRef idx="minor">
-            <a:schemeClr val="lt1"/>
-          </a:fontRef>
-        </p:style>
-        <p:txBody>
-          <a:bodyPr rtlCol="0" anchor="ctr"/>
-          <a:lstStyle/>
-          <a:p>
-            <a:pPr algn="ctr"/>
-            <a:endParaRPr lang="pt-BR" sz="2400" dirty="0">
-              <a:solidFill>
-                <a:prstClr val="white"/>
-              </a:solidFill>
-              <a:latin typeface="Calibri" panose="020F0502020204030204"/>
-            </a:endParaRPr>
-          </a:p>
-        </p:txBody>
-      </p:sp>
-      <p:sp>
-        <p:nvSpPr>
-          <p:cNvPr id="25" name="Retângulo: Cantos Arredondados 24">
-            <a:extLst>
-              <a:ext uri="{FF2B5EF4-FFF2-40B4-BE49-F238E27FC236}">
-                <a16:creationId xmlns:a16="http://schemas.microsoft.com/office/drawing/2014/main" id="{C1E9C046-7A48-2D7B-0FB4-2D257A9168A5}"/>
-              </a:ext>
-            </a:extLst>
-          </p:cNvPr>
-          <p:cNvSpPr/>
-          <p:nvPr/>
-        </p:nvSpPr>
-        <p:spPr>
-          <a:xfrm>
-            <a:off x="17587321" y="9925419"/>
-            <a:ext cx="995739" cy="8914123"/>
-          </a:xfrm>
-          <a:prstGeom prst="roundRect">
-            <a:avLst>
-              <a:gd name="adj" fmla="val 24349"/>
-            </a:avLst>
-          </a:prstGeom>
-          <a:gradFill flip="none" rotWithShape="1">
-            <a:gsLst>
-              <a:gs pos="0">
-                <a:srgbClr val="05324B"/>
-              </a:gs>
-              <a:gs pos="62000">
-                <a:srgbClr val="032030"/>
-              </a:gs>
-              <a:gs pos="76000">
-                <a:srgbClr val="032030"/>
-              </a:gs>
-              <a:gs pos="100000">
-                <a:srgbClr val="032030"/>
-              </a:gs>
-            </a:gsLst>
-            <a:lin ang="2700000" scaled="1"/>
-            <a:tileRect/>
-          </a:gradFill>
-          <a:ln>
-            <a:solidFill>
-              <a:srgbClr val="074365"/>
-            </a:solidFill>
-          </a:ln>
-          <a:effectLst>
-            <a:outerShdw blurRad="50800" dist="38100" dir="3300000" algn="t" rotWithShape="0">
-              <a:schemeClr val="bg1">
-                <a:alpha val="40000"/>
-              </a:schemeClr>
-            </a:outerShdw>
-          </a:effectLst>
-        </p:spPr>
-        <p:style>
-          <a:lnRef idx="2">
-            <a:schemeClr val="accent1">
-              <a:shade val="50000"/>
-            </a:schemeClr>
-          </a:lnRef>
-          <a:fillRef idx="1">
-            <a:schemeClr val="accent1"/>
-          </a:fillRef>
-          <a:effectRef idx="0">
-            <a:schemeClr val="accent1"/>
-          </a:effectRef>
-          <a:fontRef idx="minor">
-            <a:schemeClr val="lt1"/>
-          </a:fontRef>
-        </p:style>
-        <p:txBody>
-          <a:bodyPr vert="vert" rtlCol="0" anchor="ctr"/>
-          <a:lstStyle/>
-          <a:p>
-            <a:pPr algn="ctr"/>
-            <a:endParaRPr lang="pt-BR" sz="3467" dirty="0">
-              <a:solidFill>
-                <a:schemeClr val="bg1"/>
-              </a:solidFill>
-              <a:latin typeface="Din"/>
-            </a:endParaRPr>
-          </a:p>
-        </p:txBody>
-      </p:sp>
-      <p:pic>
-        <p:nvPicPr>
-          <p:cNvPr id="12" name="Imagem 11" descr="Forma, Retângulo&#10;&#10;O conteúdo gerado por IA pode estar incorreto.">
-            <a:extLst>
-              <a:ext uri="{FF2B5EF4-FFF2-40B4-BE49-F238E27FC236}">
-                <a16:creationId xmlns:a16="http://schemas.microsoft.com/office/drawing/2014/main" id="{C7C1CDF9-5A4C-ED62-3394-09E4A8450B1A}"/>
-              </a:ext>
-            </a:extLst>
-          </p:cNvPr>
-          <p:cNvPicPr>
-            <a:picLocks noChangeAspect="1"/>
-          </p:cNvPicPr>
-          <p:nvPr/>
-        </p:nvPicPr>
-        <p:blipFill>
-          <a:blip r:embed="rId2">
-            <a:duotone>
-              <a:prstClr val="black"/>
-              <a:schemeClr val="tx2">
-                <a:tint val="45000"/>
-                <a:satMod val="400000"/>
-              </a:schemeClr>
-            </a:duotone>
-            <a:extLst>
-              <a:ext uri="{28A0092B-C50C-407E-A947-70E740481C1C}">
-                <a14:useLocalDpi xmlns:a14="http://schemas.microsoft.com/office/drawing/2010/main" val="0"/>
-              </a:ext>
-            </a:extLst>
-          </a:blip>
-          <a:stretch>
-            <a:fillRect/>
-          </a:stretch>
-        </p:blipFill>
-        <p:spPr>
-          <a:xfrm>
-            <a:off x="17820140" y="10540940"/>
-            <a:ext cx="532660" cy="532660"/>
-          </a:xfrm>
-          <a:prstGeom prst="rect">
-            <a:avLst/>
-          </a:prstGeom>
-        </p:spPr>
-      </p:pic>
-      <p:grpSp>
-        <p:nvGrpSpPr>
-          <p:cNvPr id="23" name="Agrupar 22">
-            <a:extLst>
-              <a:ext uri="{FF2B5EF4-FFF2-40B4-BE49-F238E27FC236}">
-                <a16:creationId xmlns:a16="http://schemas.microsoft.com/office/drawing/2014/main" id="{527A7EC9-6BFC-1153-5960-1965065C7893}"/>
-              </a:ext>
-            </a:extLst>
-          </p:cNvPr>
-          <p:cNvGrpSpPr/>
-          <p:nvPr/>
-        </p:nvGrpSpPr>
-        <p:grpSpPr>
-          <a:xfrm>
-            <a:off x="18727384" y="9925416"/>
-            <a:ext cx="14887700" cy="995739"/>
-            <a:chOff x="18536024" y="9879342"/>
-            <a:chExt cx="15529937" cy="1122481"/>
-          </a:xfrm>
-        </p:grpSpPr>
-        <p:sp>
-          <p:nvSpPr>
-            <p:cNvPr id="6" name="Retângulo: Cantos Arredondados 5">
-              <a:extLst>
-                <a:ext uri="{FF2B5EF4-FFF2-40B4-BE49-F238E27FC236}">
-                  <a16:creationId xmlns:a16="http://schemas.microsoft.com/office/drawing/2014/main" id="{58838DD1-2828-F091-45F4-5109DF25FAE9}"/>
-                </a:ext>
-              </a:extLst>
-            </p:cNvPr>
-            <p:cNvSpPr/>
-            <p:nvPr/>
-          </p:nvSpPr>
-          <p:spPr>
-            <a:xfrm rot="16200000">
-              <a:off x="25739752" y="2675614"/>
-              <a:ext cx="1122481" cy="15529937"/>
-            </a:xfrm>
-            <a:prstGeom prst="roundRect">
-              <a:avLst>
-                <a:gd name="adj" fmla="val 24349"/>
-              </a:avLst>
-            </a:prstGeom>
-            <a:gradFill flip="none" rotWithShape="1">
-              <a:gsLst>
-                <a:gs pos="0">
-                  <a:srgbClr val="05324B"/>
-                </a:gs>
-                <a:gs pos="62000">
-                  <a:srgbClr val="032030"/>
-                </a:gs>
-                <a:gs pos="76000">
-                  <a:srgbClr val="032030"/>
-                </a:gs>
-                <a:gs pos="100000">
-                  <a:srgbClr val="032030"/>
-                </a:gs>
-              </a:gsLst>
-              <a:lin ang="2700000" scaled="1"/>
-              <a:tileRect/>
-            </a:gradFill>
-            <a:ln>
-              <a:solidFill>
-                <a:srgbClr val="074365"/>
-              </a:solidFill>
-            </a:ln>
-            <a:effectLst>
-              <a:outerShdw blurRad="50800" dist="38100" dir="3300000" algn="t" rotWithShape="0">
-                <a:schemeClr val="bg1">
-                  <a:alpha val="40000"/>
-                </a:schemeClr>
-              </a:outerShdw>
-            </a:effectLst>
-          </p:spPr>
-          <p:style>
-            <a:lnRef idx="2">
-              <a:schemeClr val="accent1">
-                <a:shade val="50000"/>
-              </a:schemeClr>
-            </a:lnRef>
-            <a:fillRef idx="1">
-              <a:schemeClr val="accent1"/>
-            </a:fillRef>
-            <a:effectRef idx="0">
-              <a:schemeClr val="accent1"/>
-            </a:effectRef>
-            <a:fontRef idx="minor">
-              <a:schemeClr val="lt1"/>
-            </a:fontRef>
-          </p:style>
-          <p:txBody>
-            <a:bodyPr vert="vert" rtlCol="0" anchor="ctr"/>
-            <a:lstStyle/>
-            <a:p>
-              <a:pPr algn="ctr"/>
-              <a:endParaRPr lang="pt-BR" sz="3467" dirty="0">
-                <a:solidFill>
-                  <a:schemeClr val="bg1"/>
-                </a:solidFill>
-                <a:latin typeface="Din"/>
-              </a:endParaRPr>
-            </a:p>
-          </p:txBody>
-        </p:sp>
-        <p:sp>
-          <p:nvSpPr>
-            <p:cNvPr id="3" name="CaixaDeTexto 2">
-              <a:extLst>
-                <a:ext uri="{FF2B5EF4-FFF2-40B4-BE49-F238E27FC236}">
-                  <a16:creationId xmlns:a16="http://schemas.microsoft.com/office/drawing/2014/main" id="{9EB0D3C0-D759-01D5-B3CC-2089B6DDD901}"/>
-                </a:ext>
-              </a:extLst>
-            </p:cNvPr>
-            <p:cNvSpPr txBox="1"/>
-            <p:nvPr/>
-          </p:nvSpPr>
-          <p:spPr>
-            <a:xfrm>
-              <a:off x="18654381" y="10005809"/>
-              <a:ext cx="15411579" cy="589818"/>
+              <a:ext cx="13791531" cy="589818"/>
             </a:xfrm>
             <a:prstGeom prst="rect">
               <a:avLst/>
@@ -5460,7 +4415,7 @@
             <p:cNvPr id="8" name="CaixaDeTexto 7">
               <a:extLst>
                 <a:ext uri="{FF2B5EF4-FFF2-40B4-BE49-F238E27FC236}">
-                  <a16:creationId xmlns:a16="http://schemas.microsoft.com/office/drawing/2014/main" id="{EA614EE7-1412-0D02-7AA9-28392EC791F8}"/>
+                  <a16:creationId xmlns:a16="http://schemas.microsoft.com/office/drawing/2014/main" id="{E41C1DBA-F2A3-A81A-025D-DB0CB07A0C2C}"/>
                 </a:ext>
               </a:extLst>
             </p:cNvPr>
@@ -5469,8 +4424,8 @@
           </p:nvSpPr>
           <p:spPr>
             <a:xfrm>
-              <a:off x="18654382" y="10581735"/>
-              <a:ext cx="15411578" cy="346952"/>
+              <a:off x="18891466" y="10581735"/>
+              <a:ext cx="13791531" cy="346952"/>
             </a:xfrm>
             <a:prstGeom prst="rect">
               <a:avLst/>
@@ -5521,10 +4476,10 @@
       </p:grpSp>
       <p:sp>
         <p:nvSpPr>
-          <p:cNvPr id="49" name="Retângulo: Cantos Arredondados 48">
+          <p:cNvPr id="27" name="Retângulo: Cantos Arredondados 26">
             <a:extLst>
               <a:ext uri="{FF2B5EF4-FFF2-40B4-BE49-F238E27FC236}">
-                <a16:creationId xmlns:a16="http://schemas.microsoft.com/office/drawing/2014/main" id="{4EDE8996-7474-5237-3AE3-4AFE4A009C1C}"/>
+                <a16:creationId xmlns:a16="http://schemas.microsoft.com/office/drawing/2014/main" id="{D47BA7C0-4604-0164-6353-C6A63304EA5D}"/>
               </a:ext>
             </a:extLst>
           </p:cNvPr>
@@ -5533,8 +4488,8 @@
         </p:nvSpPr>
         <p:spPr>
           <a:xfrm>
-            <a:off x="26212799" y="13059518"/>
-            <a:ext cx="7402285" cy="2825929"/>
+            <a:off x="18698354" y="12748980"/>
+            <a:ext cx="7387446" cy="3037120"/>
           </a:xfrm>
           <a:prstGeom prst="roundRect">
             <a:avLst>
@@ -5587,10 +4542,10 @@
       </p:sp>
       <p:sp>
         <p:nvSpPr>
-          <p:cNvPr id="51" name="Retângulo: Cantos Arredondados 50">
+          <p:cNvPr id="62" name="Retângulo: Cantos Arredondados 61">
             <a:extLst>
               <a:ext uri="{FF2B5EF4-FFF2-40B4-BE49-F238E27FC236}">
-                <a16:creationId xmlns:a16="http://schemas.microsoft.com/office/drawing/2014/main" id="{9D97E0AA-D932-88B7-6E98-2D0B0903B99A}"/>
+                <a16:creationId xmlns:a16="http://schemas.microsoft.com/office/drawing/2014/main" id="{54CE131E-9AA6-5376-F90A-BA4B311AFBBF}"/>
               </a:ext>
             </a:extLst>
           </p:cNvPr>
@@ -5599,8 +4554,330 @@
         </p:nvSpPr>
         <p:spPr>
           <a:xfrm>
-            <a:off x="26212799" y="16013612"/>
-            <a:ext cx="7402285" cy="2825929"/>
+            <a:off x="22090681" y="11075213"/>
+            <a:ext cx="2573924" cy="1519713"/>
+          </a:xfrm>
+          <a:prstGeom prst="roundRect">
+            <a:avLst/>
+          </a:prstGeom>
+          <a:solidFill>
+            <a:schemeClr val="bg1"/>
+          </a:solidFill>
+          <a:ln>
+            <a:noFill/>
+          </a:ln>
+          <a:effectLst>
+            <a:outerShdw blurRad="50800" dist="38100" dir="5400000" algn="t" rotWithShape="0">
+              <a:srgbClr val="05324B">
+                <a:alpha val="40000"/>
+              </a:srgbClr>
+            </a:outerShdw>
+          </a:effectLst>
+        </p:spPr>
+        <p:style>
+          <a:lnRef idx="2">
+            <a:schemeClr val="accent1">
+              <a:shade val="50000"/>
+            </a:schemeClr>
+          </a:lnRef>
+          <a:fillRef idx="1">
+            <a:schemeClr val="accent1"/>
+          </a:fillRef>
+          <a:effectRef idx="0">
+            <a:schemeClr val="accent1"/>
+          </a:effectRef>
+          <a:fontRef idx="minor">
+            <a:schemeClr val="lt1"/>
+          </a:fontRef>
+        </p:style>
+        <p:txBody>
+          <a:bodyPr rtlCol="0" anchor="ctr"/>
+          <a:lstStyle/>
+          <a:p>
+            <a:pPr algn="ctr"/>
+            <a:endParaRPr lang="pt-BR" sz="2400">
+              <a:solidFill>
+                <a:prstClr val="white"/>
+              </a:solidFill>
+              <a:latin typeface="Calibri" panose="020F0502020204030204"/>
+            </a:endParaRPr>
+          </a:p>
+        </p:txBody>
+      </p:sp>
+      <p:sp>
+        <p:nvSpPr>
+          <p:cNvPr id="63" name="Retângulo: Cantos Arredondados 62">
+            <a:extLst>
+              <a:ext uri="{FF2B5EF4-FFF2-40B4-BE49-F238E27FC236}">
+                <a16:creationId xmlns:a16="http://schemas.microsoft.com/office/drawing/2014/main" id="{44F082B5-0DA2-56FE-C6D7-56119385B762}"/>
+              </a:ext>
+            </a:extLst>
+          </p:cNvPr>
+          <p:cNvSpPr/>
+          <p:nvPr/>
+        </p:nvSpPr>
+        <p:spPr>
+          <a:xfrm>
+            <a:off x="24877460" y="11075213"/>
+            <a:ext cx="2573924" cy="1519713"/>
+          </a:xfrm>
+          <a:prstGeom prst="roundRect">
+            <a:avLst/>
+          </a:prstGeom>
+          <a:solidFill>
+            <a:schemeClr val="bg1"/>
+          </a:solidFill>
+          <a:ln>
+            <a:noFill/>
+          </a:ln>
+          <a:effectLst>
+            <a:outerShdw blurRad="50800" dist="38100" dir="5400000" algn="t" rotWithShape="0">
+              <a:srgbClr val="05324B">
+                <a:alpha val="40000"/>
+              </a:srgbClr>
+            </a:outerShdw>
+          </a:effectLst>
+        </p:spPr>
+        <p:style>
+          <a:lnRef idx="2">
+            <a:schemeClr val="accent1">
+              <a:shade val="50000"/>
+            </a:schemeClr>
+          </a:lnRef>
+          <a:fillRef idx="1">
+            <a:schemeClr val="accent1"/>
+          </a:fillRef>
+          <a:effectRef idx="0">
+            <a:schemeClr val="accent1"/>
+          </a:effectRef>
+          <a:fontRef idx="minor">
+            <a:schemeClr val="lt1"/>
+          </a:fontRef>
+        </p:style>
+        <p:txBody>
+          <a:bodyPr rtlCol="0" anchor="ctr"/>
+          <a:lstStyle/>
+          <a:p>
+            <a:pPr algn="ctr"/>
+            <a:endParaRPr lang="pt-BR" sz="2400">
+              <a:solidFill>
+                <a:prstClr val="white"/>
+              </a:solidFill>
+              <a:latin typeface="Calibri" panose="020F0502020204030204"/>
+            </a:endParaRPr>
+          </a:p>
+        </p:txBody>
+      </p:sp>
+      <p:sp>
+        <p:nvSpPr>
+          <p:cNvPr id="64" name="Retângulo: Cantos Arredondados 63">
+            <a:extLst>
+              <a:ext uri="{FF2B5EF4-FFF2-40B4-BE49-F238E27FC236}">
+                <a16:creationId xmlns:a16="http://schemas.microsoft.com/office/drawing/2014/main" id="{86FCBD4A-570D-099B-EDF6-19810CBAF97E}"/>
+              </a:ext>
+            </a:extLst>
+          </p:cNvPr>
+          <p:cNvSpPr/>
+          <p:nvPr/>
+        </p:nvSpPr>
+        <p:spPr>
+          <a:xfrm>
+            <a:off x="27664239" y="11075213"/>
+            <a:ext cx="2573924" cy="1519713"/>
+          </a:xfrm>
+          <a:prstGeom prst="roundRect">
+            <a:avLst/>
+          </a:prstGeom>
+          <a:solidFill>
+            <a:schemeClr val="bg1"/>
+          </a:solidFill>
+          <a:ln>
+            <a:noFill/>
+          </a:ln>
+          <a:effectLst>
+            <a:outerShdw blurRad="50800" dist="38100" dir="5400000" algn="t" rotWithShape="0">
+              <a:srgbClr val="05324B">
+                <a:alpha val="40000"/>
+              </a:srgbClr>
+            </a:outerShdw>
+          </a:effectLst>
+        </p:spPr>
+        <p:style>
+          <a:lnRef idx="2">
+            <a:schemeClr val="accent1">
+              <a:shade val="50000"/>
+            </a:schemeClr>
+          </a:lnRef>
+          <a:fillRef idx="1">
+            <a:schemeClr val="accent1"/>
+          </a:fillRef>
+          <a:effectRef idx="0">
+            <a:schemeClr val="accent1"/>
+          </a:effectRef>
+          <a:fontRef idx="minor">
+            <a:schemeClr val="lt1"/>
+          </a:fontRef>
+        </p:style>
+        <p:txBody>
+          <a:bodyPr rtlCol="0" anchor="ctr"/>
+          <a:lstStyle/>
+          <a:p>
+            <a:pPr algn="ctr"/>
+            <a:endParaRPr lang="pt-BR" sz="2400">
+              <a:solidFill>
+                <a:prstClr val="white"/>
+              </a:solidFill>
+              <a:latin typeface="Calibri" panose="020F0502020204030204"/>
+            </a:endParaRPr>
+          </a:p>
+        </p:txBody>
+      </p:sp>
+      <p:pic>
+        <p:nvPicPr>
+          <p:cNvPr id="66" name="Imagem 65" descr="Ícone&#10;&#10;O conteúdo gerado por IA pode estar incorreto.">
+            <a:extLst>
+              <a:ext uri="{FF2B5EF4-FFF2-40B4-BE49-F238E27FC236}">
+                <a16:creationId xmlns:a16="http://schemas.microsoft.com/office/drawing/2014/main" id="{83ABFDCB-63D0-18AA-5162-9C42B90F83FE}"/>
+              </a:ext>
+            </a:extLst>
+          </p:cNvPr>
+          <p:cNvPicPr>
+            <a:picLocks noChangeAspect="1"/>
+          </p:cNvPicPr>
+          <p:nvPr/>
+        </p:nvPicPr>
+        <p:blipFill>
+          <a:blip r:embed="rId3">
+            <a:duotone>
+              <a:prstClr val="black"/>
+              <a:schemeClr val="tx2">
+                <a:tint val="45000"/>
+                <a:satMod val="400000"/>
+              </a:schemeClr>
+            </a:duotone>
+            <a:extLst>
+              <a:ext uri="{28A0092B-C50C-407E-A947-70E740481C1C}">
+                <a14:useLocalDpi xmlns:a14="http://schemas.microsoft.com/office/drawing/2010/main" val="0"/>
+              </a:ext>
+            </a:extLst>
+          </a:blip>
+          <a:stretch>
+            <a:fillRect/>
+          </a:stretch>
+        </p:blipFill>
+        <p:spPr>
+          <a:xfrm>
+            <a:off x="17820139" y="13678050"/>
+            <a:ext cx="532661" cy="532661"/>
+          </a:xfrm>
+          <a:prstGeom prst="rect">
+            <a:avLst/>
+          </a:prstGeom>
+        </p:spPr>
+      </p:pic>
+      <p:pic>
+        <p:nvPicPr>
+          <p:cNvPr id="67" name="Imagem 66" descr="Ícone&#10;&#10;O conteúdo gerado por IA pode estar incorreto.">
+            <a:extLst>
+              <a:ext uri="{FF2B5EF4-FFF2-40B4-BE49-F238E27FC236}">
+                <a16:creationId xmlns:a16="http://schemas.microsoft.com/office/drawing/2014/main" id="{89E6F8FC-7B3D-CA4C-9D48-5EF723113782}"/>
+              </a:ext>
+            </a:extLst>
+          </p:cNvPr>
+          <p:cNvPicPr>
+            <a:picLocks noChangeAspect="1"/>
+          </p:cNvPicPr>
+          <p:nvPr/>
+        </p:nvPicPr>
+        <p:blipFill>
+          <a:blip r:embed="rId4">
+            <a:extLst>
+              <a:ext uri="{28A0092B-C50C-407E-A947-70E740481C1C}">
+                <a14:useLocalDpi xmlns:a14="http://schemas.microsoft.com/office/drawing/2010/main" val="0"/>
+              </a:ext>
+            </a:extLst>
+          </a:blip>
+          <a:stretch>
+            <a:fillRect/>
+          </a:stretch>
+        </p:blipFill>
+        <p:spPr>
+          <a:xfrm>
+            <a:off x="17820140" y="11586643"/>
+            <a:ext cx="532661" cy="532661"/>
+          </a:xfrm>
+          <a:prstGeom prst="rect">
+            <a:avLst/>
+          </a:prstGeom>
+          <a:effectLst>
+            <a:glow rad="63500">
+              <a:schemeClr val="accent1">
+                <a:satMod val="175000"/>
+                <a:alpha val="40000"/>
+              </a:schemeClr>
+            </a:glow>
+          </a:effectLst>
+        </p:spPr>
+      </p:pic>
+      <p:pic>
+        <p:nvPicPr>
+          <p:cNvPr id="68" name="Imagem 67" descr="Ícone&#10;&#10;O conteúdo gerado por IA pode estar incorreto.">
+            <a:extLst>
+              <a:ext uri="{FF2B5EF4-FFF2-40B4-BE49-F238E27FC236}">
+                <a16:creationId xmlns:a16="http://schemas.microsoft.com/office/drawing/2014/main" id="{9B121555-8D51-DA4C-E218-3EE23B5F3592}"/>
+              </a:ext>
+            </a:extLst>
+          </p:cNvPr>
+          <p:cNvPicPr>
+            <a:picLocks noChangeAspect="1"/>
+          </p:cNvPicPr>
+          <p:nvPr/>
+        </p:nvPicPr>
+        <p:blipFill>
+          <a:blip r:embed="rId5">
+            <a:duotone>
+              <a:prstClr val="black"/>
+              <a:schemeClr val="tx2">
+                <a:tint val="45000"/>
+                <a:satMod val="400000"/>
+              </a:schemeClr>
+            </a:duotone>
+            <a:extLst>
+              <a:ext uri="{28A0092B-C50C-407E-A947-70E740481C1C}">
+                <a14:useLocalDpi xmlns:a14="http://schemas.microsoft.com/office/drawing/2010/main" val="0"/>
+              </a:ext>
+            </a:extLst>
+          </a:blip>
+          <a:stretch>
+            <a:fillRect/>
+          </a:stretch>
+        </p:blipFill>
+        <p:spPr>
+          <a:xfrm>
+            <a:off x="17820140" y="12646861"/>
+            <a:ext cx="532660" cy="532660"/>
+          </a:xfrm>
+          <a:prstGeom prst="rect">
+            <a:avLst/>
+          </a:prstGeom>
+        </p:spPr>
+      </p:pic>
+      <p:sp>
+        <p:nvSpPr>
+          <p:cNvPr id="10" name="Retângulo: Cantos Arredondados 9">
+            <a:extLst>
+              <a:ext uri="{FF2B5EF4-FFF2-40B4-BE49-F238E27FC236}">
+                <a16:creationId xmlns:a16="http://schemas.microsoft.com/office/drawing/2014/main" id="{283D9E9F-4D34-8BB4-9110-82A1561CF348}"/>
+              </a:ext>
+            </a:extLst>
+          </p:cNvPr>
+          <p:cNvSpPr/>
+          <p:nvPr/>
+        </p:nvSpPr>
+        <p:spPr>
+          <a:xfrm>
+            <a:off x="18712533" y="15935112"/>
+            <a:ext cx="7387446" cy="3037120"/>
           </a:xfrm>
           <a:prstGeom prst="roundRect">
             <a:avLst>
@@ -5653,10 +4930,10 @@
       </p:sp>
       <p:sp>
         <p:nvSpPr>
-          <p:cNvPr id="62" name="Retângulo: Cantos Arredondados 61">
+          <p:cNvPr id="11" name="Retângulo: Cantos Arredondados 10">
             <a:extLst>
               <a:ext uri="{FF2B5EF4-FFF2-40B4-BE49-F238E27FC236}">
-                <a16:creationId xmlns:a16="http://schemas.microsoft.com/office/drawing/2014/main" id="{84AACBCE-3322-3714-A575-981A63B60324}"/>
+                <a16:creationId xmlns:a16="http://schemas.microsoft.com/office/drawing/2014/main" id="{8E49FDCD-F019-02B3-753A-9CFE5FA4CD09}"/>
               </a:ext>
             </a:extLst>
           </p:cNvPr>
@@ -5665,202 +4942,8 @@
         </p:nvSpPr>
         <p:spPr>
           <a:xfrm>
-            <a:off x="18698354" y="11197482"/>
-            <a:ext cx="2412000" cy="1602422"/>
-          </a:xfrm>
-          <a:prstGeom prst="roundRect">
-            <a:avLst/>
-          </a:prstGeom>
-          <a:solidFill>
-            <a:schemeClr val="bg1"/>
-          </a:solidFill>
-          <a:ln>
-            <a:noFill/>
-          </a:ln>
-          <a:effectLst>
-            <a:outerShdw blurRad="50800" dist="38100" dir="5400000" algn="t" rotWithShape="0">
-              <a:srgbClr val="05324B">
-                <a:alpha val="40000"/>
-              </a:srgbClr>
-            </a:outerShdw>
-          </a:effectLst>
-        </p:spPr>
-        <p:style>
-          <a:lnRef idx="2">
-            <a:schemeClr val="accent1">
-              <a:shade val="50000"/>
-            </a:schemeClr>
-          </a:lnRef>
-          <a:fillRef idx="1">
-            <a:schemeClr val="accent1"/>
-          </a:fillRef>
-          <a:effectRef idx="0">
-            <a:schemeClr val="accent1"/>
-          </a:effectRef>
-          <a:fontRef idx="minor">
-            <a:schemeClr val="lt1"/>
-          </a:fontRef>
-        </p:style>
-        <p:txBody>
-          <a:bodyPr rtlCol="0" anchor="ctr"/>
-          <a:lstStyle/>
-          <a:p>
-            <a:pPr algn="ctr"/>
-            <a:endParaRPr lang="pt-BR" sz="2400">
-              <a:solidFill>
-                <a:prstClr val="white"/>
-              </a:solidFill>
-              <a:latin typeface="Calibri" panose="020F0502020204030204"/>
-            </a:endParaRPr>
-          </a:p>
-        </p:txBody>
-      </p:sp>
-      <p:pic>
-        <p:nvPicPr>
-          <p:cNvPr id="66" name="Imagem 65" descr="Ícone&#10;&#10;O conteúdo gerado por IA pode estar incorreto.">
-            <a:extLst>
-              <a:ext uri="{FF2B5EF4-FFF2-40B4-BE49-F238E27FC236}">
-                <a16:creationId xmlns:a16="http://schemas.microsoft.com/office/drawing/2014/main" id="{6B5E8C78-C216-0050-DACE-C27C91387C73}"/>
-              </a:ext>
-            </a:extLst>
-          </p:cNvPr>
-          <p:cNvPicPr>
-            <a:picLocks noChangeAspect="1"/>
-          </p:cNvPicPr>
-          <p:nvPr/>
-        </p:nvPicPr>
-        <p:blipFill>
-          <a:blip r:embed="rId3">
-            <a:duotone>
-              <a:prstClr val="black"/>
-              <a:schemeClr val="tx2">
-                <a:tint val="45000"/>
-                <a:satMod val="400000"/>
-              </a:schemeClr>
-            </a:duotone>
-            <a:extLst>
-              <a:ext uri="{28A0092B-C50C-407E-A947-70E740481C1C}">
-                <a14:useLocalDpi xmlns:a14="http://schemas.microsoft.com/office/drawing/2010/main" val="0"/>
-              </a:ext>
-            </a:extLst>
-          </a:blip>
-          <a:stretch>
-            <a:fillRect/>
-          </a:stretch>
-        </p:blipFill>
-        <p:spPr>
-          <a:xfrm>
-            <a:off x="17820139" y="13678050"/>
-            <a:ext cx="532661" cy="532661"/>
-          </a:xfrm>
-          <a:prstGeom prst="rect">
-            <a:avLst/>
-          </a:prstGeom>
-        </p:spPr>
-      </p:pic>
-      <p:pic>
-        <p:nvPicPr>
-          <p:cNvPr id="67" name="Imagem 66" descr="Ícone&#10;&#10;O conteúdo gerado por IA pode estar incorreto.">
-            <a:extLst>
-              <a:ext uri="{FF2B5EF4-FFF2-40B4-BE49-F238E27FC236}">
-                <a16:creationId xmlns:a16="http://schemas.microsoft.com/office/drawing/2014/main" id="{D90C122E-59CA-D5E6-6697-54FD9B994DD5}"/>
-              </a:ext>
-            </a:extLst>
-          </p:cNvPr>
-          <p:cNvPicPr>
-            <a:picLocks noChangeAspect="1"/>
-          </p:cNvPicPr>
-          <p:nvPr/>
-        </p:nvPicPr>
-        <p:blipFill>
-          <a:blip r:embed="rId4">
-            <a:extLst>
-              <a:ext uri="{28A0092B-C50C-407E-A947-70E740481C1C}">
-                <a14:useLocalDpi xmlns:a14="http://schemas.microsoft.com/office/drawing/2010/main" val="0"/>
-              </a:ext>
-            </a:extLst>
-          </a:blip>
-          <a:stretch>
-            <a:fillRect/>
-          </a:stretch>
-        </p:blipFill>
-        <p:spPr>
-          <a:xfrm>
-            <a:off x="17820140" y="11586643"/>
-            <a:ext cx="532661" cy="532661"/>
-          </a:xfrm>
-          <a:prstGeom prst="rect">
-            <a:avLst/>
-          </a:prstGeom>
-          <a:effectLst>
-            <a:glow rad="63500">
-              <a:schemeClr val="accent1">
-                <a:satMod val="175000"/>
-                <a:alpha val="40000"/>
-              </a:schemeClr>
-            </a:glow>
-          </a:effectLst>
-        </p:spPr>
-      </p:pic>
-      <p:pic>
-        <p:nvPicPr>
-          <p:cNvPr id="68" name="Imagem 67" descr="Ícone&#10;&#10;O conteúdo gerado por IA pode estar incorreto.">
-            <a:extLst>
-              <a:ext uri="{FF2B5EF4-FFF2-40B4-BE49-F238E27FC236}">
-                <a16:creationId xmlns:a16="http://schemas.microsoft.com/office/drawing/2014/main" id="{B7BF406F-55AC-81A3-BFE8-A0E9FB5DFAD3}"/>
-              </a:ext>
-            </a:extLst>
-          </p:cNvPr>
-          <p:cNvPicPr>
-            <a:picLocks noChangeAspect="1"/>
-          </p:cNvPicPr>
-          <p:nvPr/>
-        </p:nvPicPr>
-        <p:blipFill>
-          <a:blip r:embed="rId5">
-            <a:duotone>
-              <a:prstClr val="black"/>
-              <a:schemeClr val="tx2">
-                <a:tint val="45000"/>
-                <a:satMod val="400000"/>
-              </a:schemeClr>
-            </a:duotone>
-            <a:extLst>
-              <a:ext uri="{28A0092B-C50C-407E-A947-70E740481C1C}">
-                <a14:useLocalDpi xmlns:a14="http://schemas.microsoft.com/office/drawing/2010/main" val="0"/>
-              </a:ext>
-            </a:extLst>
-          </a:blip>
-          <a:stretch>
-            <a:fillRect/>
-          </a:stretch>
-        </p:blipFill>
-        <p:spPr>
-          <a:xfrm>
-            <a:off x="17820140" y="12646861"/>
-            <a:ext cx="532660" cy="532660"/>
-          </a:xfrm>
-          <a:prstGeom prst="rect">
-            <a:avLst/>
-          </a:prstGeom>
-        </p:spPr>
-      </p:pic>
-      <p:sp>
-        <p:nvSpPr>
-          <p:cNvPr id="7" name="Retângulo: Cantos Arredondados 6">
-            <a:extLst>
-              <a:ext uri="{FF2B5EF4-FFF2-40B4-BE49-F238E27FC236}">
-                <a16:creationId xmlns:a16="http://schemas.microsoft.com/office/drawing/2014/main" id="{5D2B3A6C-44D0-EA54-CBF4-6831FCE616D1}"/>
-              </a:ext>
-            </a:extLst>
-          </p:cNvPr>
-          <p:cNvSpPr/>
-          <p:nvPr/>
-        </p:nvSpPr>
-        <p:spPr>
-          <a:xfrm>
-            <a:off x="18727382" y="13059518"/>
-            <a:ext cx="7402285" cy="2825929"/>
+            <a:off x="26215274" y="12748980"/>
+            <a:ext cx="7387446" cy="3037120"/>
           </a:xfrm>
           <a:prstGeom prst="roundRect">
             <a:avLst>
@@ -5913,10 +4996,10 @@
       </p:sp>
       <p:sp>
         <p:nvSpPr>
-          <p:cNvPr id="9" name="Retângulo: Cantos Arredondados 8">
+          <p:cNvPr id="13" name="Retângulo: Cantos Arredondados 12">
             <a:extLst>
               <a:ext uri="{FF2B5EF4-FFF2-40B4-BE49-F238E27FC236}">
-                <a16:creationId xmlns:a16="http://schemas.microsoft.com/office/drawing/2014/main" id="{0471DAFA-C88A-F0F5-E223-A6E50CABF98C}"/>
+                <a16:creationId xmlns:a16="http://schemas.microsoft.com/office/drawing/2014/main" id="{8AF68628-B478-6B5E-90B8-5D3ED4697BC5}"/>
               </a:ext>
             </a:extLst>
           </p:cNvPr>
@@ -5925,8 +5008,8 @@
         </p:nvSpPr>
         <p:spPr>
           <a:xfrm>
-            <a:off x="18727382" y="16013612"/>
-            <a:ext cx="7402285" cy="2825929"/>
+            <a:off x="26229453" y="15935112"/>
+            <a:ext cx="7387446" cy="3037120"/>
           </a:xfrm>
           <a:prstGeom prst="roundRect">
             <a:avLst>
@@ -5977,138 +5060,53 @@
           </a:p>
         </p:txBody>
       </p:sp>
-      <p:sp>
-        <p:nvSpPr>
-          <p:cNvPr id="10" name="Retângulo: Cantos Arredondados 9">
+      <p:pic>
+        <p:nvPicPr>
+          <p:cNvPr id="21" name="Imagem 20" descr="Ícone&#10;&#10;O conteúdo gerado por IA pode estar incorreto.">
             <a:extLst>
               <a:ext uri="{FF2B5EF4-FFF2-40B4-BE49-F238E27FC236}">
-                <a16:creationId xmlns:a16="http://schemas.microsoft.com/office/drawing/2014/main" id="{878F658F-84DB-2699-6E2A-78996F499B25}"/>
+                <a16:creationId xmlns:a16="http://schemas.microsoft.com/office/drawing/2014/main" id="{70849AE4-57F9-087C-12D5-068756557C50}"/>
               </a:ext>
             </a:extLst>
           </p:cNvPr>
-          <p:cNvSpPr/>
+          <p:cNvPicPr>
+            <a:picLocks noChangeAspect="1"/>
+          </p:cNvPicPr>
           <p:nvPr/>
-        </p:nvSpPr>
-        <p:spPr>
-          <a:xfrm>
-            <a:off x="21208010" y="11197482"/>
-            <a:ext cx="2412000" cy="1602422"/>
-          </a:xfrm>
-          <a:prstGeom prst="roundRect">
+        </p:nvPicPr>
+        <p:blipFill>
+          <a:blip r:embed="rId6">
+            <a:duotone>
+              <a:prstClr val="black"/>
+              <a:schemeClr val="tx2">
+                <a:tint val="45000"/>
+                <a:satMod val="400000"/>
+              </a:schemeClr>
+            </a:duotone>
+            <a:extLst>
+              <a:ext uri="{28A0092B-C50C-407E-A947-70E740481C1C}">
+                <a14:useLocalDpi xmlns:a14="http://schemas.microsoft.com/office/drawing/2010/main" val="0"/>
+              </a:ext>
+            </a:extLst>
+          </a:blip>
+          <a:stretch>
+            <a:fillRect/>
+          </a:stretch>
+        </p:blipFill>
+        <p:spPr>
+          <a:xfrm>
+            <a:off x="32714027" y="10066769"/>
+            <a:ext cx="713039" cy="713039"/>
+          </a:xfrm>
+          <a:prstGeom prst="rect">
             <a:avLst/>
           </a:prstGeom>
-          <a:solidFill>
-            <a:schemeClr val="bg1"/>
-          </a:solidFill>
-          <a:ln>
-            <a:noFill/>
-          </a:ln>
-          <a:effectLst>
-            <a:outerShdw blurRad="50800" dist="38100" dir="5400000" algn="t" rotWithShape="0">
-              <a:srgbClr val="05324B">
-                <a:alpha val="40000"/>
-              </a:srgbClr>
-            </a:outerShdw>
-          </a:effectLst>
-        </p:spPr>
-        <p:style>
-          <a:lnRef idx="2">
-            <a:schemeClr val="accent1">
-              <a:shade val="50000"/>
-            </a:schemeClr>
-          </a:lnRef>
-          <a:fillRef idx="1">
-            <a:schemeClr val="accent1"/>
-          </a:fillRef>
-          <a:effectRef idx="0">
-            <a:schemeClr val="accent1"/>
-          </a:effectRef>
-          <a:fontRef idx="minor">
-            <a:schemeClr val="lt1"/>
-          </a:fontRef>
-        </p:style>
-        <p:txBody>
-          <a:bodyPr rtlCol="0" anchor="ctr"/>
-          <a:lstStyle/>
-          <a:p>
-            <a:pPr algn="ctr"/>
-            <a:endParaRPr lang="pt-BR" sz="2400">
-              <a:solidFill>
-                <a:prstClr val="white"/>
-              </a:solidFill>
-              <a:latin typeface="Calibri" panose="020F0502020204030204"/>
-            </a:endParaRPr>
-          </a:p>
-        </p:txBody>
-      </p:sp>
-      <p:sp>
-        <p:nvSpPr>
-          <p:cNvPr id="11" name="Retângulo: Cantos Arredondados 10">
-            <a:extLst>
-              <a:ext uri="{FF2B5EF4-FFF2-40B4-BE49-F238E27FC236}">
-                <a16:creationId xmlns:a16="http://schemas.microsoft.com/office/drawing/2014/main" id="{578EBAAB-1E9A-7ED4-0D10-D99D1CA75283}"/>
-              </a:ext>
-            </a:extLst>
-          </p:cNvPr>
-          <p:cNvSpPr/>
-          <p:nvPr/>
-        </p:nvSpPr>
-        <p:spPr>
-          <a:xfrm>
-            <a:off x="23717667" y="11180770"/>
-            <a:ext cx="2412000" cy="1602422"/>
-          </a:xfrm>
-          <a:prstGeom prst="roundRect">
-            <a:avLst/>
-          </a:prstGeom>
-          <a:solidFill>
-            <a:schemeClr val="bg1"/>
-          </a:solidFill>
-          <a:ln>
-            <a:noFill/>
-          </a:ln>
-          <a:effectLst>
-            <a:outerShdw blurRad="50800" dist="38100" dir="5400000" algn="t" rotWithShape="0">
-              <a:srgbClr val="05324B">
-                <a:alpha val="40000"/>
-              </a:srgbClr>
-            </a:outerShdw>
-          </a:effectLst>
-        </p:spPr>
-        <p:style>
-          <a:lnRef idx="2">
-            <a:schemeClr val="accent1">
-              <a:shade val="50000"/>
-            </a:schemeClr>
-          </a:lnRef>
-          <a:fillRef idx="1">
-            <a:schemeClr val="accent1"/>
-          </a:fillRef>
-          <a:effectRef idx="0">
-            <a:schemeClr val="accent1"/>
-          </a:effectRef>
-          <a:fontRef idx="minor">
-            <a:schemeClr val="lt1"/>
-          </a:fontRef>
-        </p:style>
-        <p:txBody>
-          <a:bodyPr rtlCol="0" anchor="ctr"/>
-          <a:lstStyle/>
-          <a:p>
-            <a:pPr algn="ctr"/>
-            <a:endParaRPr lang="pt-BR" sz="2400">
-              <a:solidFill>
-                <a:prstClr val="white"/>
-              </a:solidFill>
-              <a:latin typeface="Calibri" panose="020F0502020204030204"/>
-            </a:endParaRPr>
-          </a:p>
-        </p:txBody>
-      </p:sp>
+        </p:spPr>
+      </p:pic>
     </p:spTree>
     <p:extLst>
       <p:ext uri="{BB962C8B-B14F-4D97-AF65-F5344CB8AC3E}">
-        <p14:creationId xmlns:p14="http://schemas.microsoft.com/office/powerpoint/2010/main" val="2491706838"/>
+        <p14:creationId xmlns:p14="http://schemas.microsoft.com/office/powerpoint/2010/main" val="1800183230"/>
       </p:ext>
     </p:extLst>
   </p:cSld>
@@ -6118,7 +5116,7 @@
 </p:sld>
 </file>
 
-<file path=ppt/slides/slide4.xml><?xml version="1.0" encoding="utf-8"?>
+<file path=ppt/slides/slide3.xml><?xml version="1.0" encoding="utf-8"?>
 <p:sld xmlns:a="http://schemas.openxmlformats.org/drawingml/2006/main" xmlns:r="http://schemas.openxmlformats.org/officeDocument/2006/relationships" xmlns:p="http://schemas.openxmlformats.org/presentationml/2006/main">
   <p:cSld>
     <p:spTree>
@@ -6126,7 +5124,7 @@
         <p:cNvPr id="1" name="">
           <a:extLst>
             <a:ext uri="{FF2B5EF4-FFF2-40B4-BE49-F238E27FC236}">
-              <a16:creationId xmlns:a16="http://schemas.microsoft.com/office/drawing/2014/main" id="{779B0485-3D6B-2ED3-D3F4-BE54E8F7AAAA}"/>
+              <a16:creationId xmlns:a16="http://schemas.microsoft.com/office/drawing/2014/main" id="{26ABF4CB-7A59-C23D-8275-AEDCAB30AB15}"/>
             </a:ext>
           </a:extLst>
         </p:cNvPr>
@@ -6146,7 +5144,7 @@
           <p:cNvPr id="37" name="Retângulo: Cantos Arredondados 36">
             <a:extLst>
               <a:ext uri="{FF2B5EF4-FFF2-40B4-BE49-F238E27FC236}">
-                <a16:creationId xmlns:a16="http://schemas.microsoft.com/office/drawing/2014/main" id="{E9B318DD-B43A-983E-ECA6-3349BB22ADAA}"/>
+                <a16:creationId xmlns:a16="http://schemas.microsoft.com/office/drawing/2014/main" id="{B85139BC-A3E7-8080-4CE3-A574D280494C}"/>
               </a:ext>
             </a:extLst>
           </p:cNvPr>
@@ -6156,7 +5154,7 @@
         <p:spPr>
           <a:xfrm>
             <a:off x="17472027" y="9852690"/>
-            <a:ext cx="16255996" cy="9119542"/>
+            <a:ext cx="16255996" cy="9260810"/>
           </a:xfrm>
           <a:prstGeom prst="roundRect">
             <a:avLst>
@@ -6207,7 +5205,7 @@
           <p:cNvPr id="25" name="Retângulo: Cantos Arredondados 24">
             <a:extLst>
               <a:ext uri="{FF2B5EF4-FFF2-40B4-BE49-F238E27FC236}">
-                <a16:creationId xmlns:a16="http://schemas.microsoft.com/office/drawing/2014/main" id="{CC14EFB0-304F-BA69-3575-C46BCB39B2B8}"/>
+                <a16:creationId xmlns:a16="http://schemas.microsoft.com/office/drawing/2014/main" id="{B89421A9-E410-D9C6-FB2F-65B7D9455C4A}"/>
               </a:ext>
             </a:extLst>
           </p:cNvPr>
@@ -6217,7 +5215,7 @@
         <p:spPr>
           <a:xfrm>
             <a:off x="17587321" y="9925420"/>
-            <a:ext cx="995739" cy="8770902"/>
+            <a:ext cx="995739" cy="9046812"/>
           </a:xfrm>
           <a:prstGeom prst="roundRect">
             <a:avLst>
@@ -6287,10 +5285,10 @@
       </p:sp>
       <p:pic>
         <p:nvPicPr>
-          <p:cNvPr id="54" name="Imagem 53">
+          <p:cNvPr id="12" name="Imagem 11" descr="Forma, Retângulo&#10;&#10;O conteúdo gerado por IA pode estar incorreto.">
             <a:extLst>
               <a:ext uri="{FF2B5EF4-FFF2-40B4-BE49-F238E27FC236}">
-                <a16:creationId xmlns:a16="http://schemas.microsoft.com/office/drawing/2014/main" id="{F6372A70-261E-B37E-D6E1-02B23E7989DD}"/>
+                <a16:creationId xmlns:a16="http://schemas.microsoft.com/office/drawing/2014/main" id="{FB1F68CF-FB06-7001-E551-601FD92B8C41}"/>
               </a:ext>
             </a:extLst>
           </p:cNvPr>
@@ -6300,37 +5298,7 @@
           <p:nvPr/>
         </p:nvPicPr>
         <p:blipFill>
-          <a:blip r:embed="rId2"/>
-          <a:stretch>
-            <a:fillRect/>
-          </a:stretch>
-        </p:blipFill>
-        <p:spPr>
-          <a:xfrm>
-            <a:off x="32775827" y="10067041"/>
-            <a:ext cx="795715" cy="722269"/>
-          </a:xfrm>
-          <a:prstGeom prst="rect">
-            <a:avLst/>
-          </a:prstGeom>
-        </p:spPr>
-      </p:pic>
-      <p:pic>
-        <p:nvPicPr>
-          <p:cNvPr id="12" name="Imagem 11" descr="Forma, Retângulo&#10;&#10;O conteúdo gerado por IA pode estar incorreto.">
-            <a:extLst>
-              <a:ext uri="{FF2B5EF4-FFF2-40B4-BE49-F238E27FC236}">
-                <a16:creationId xmlns:a16="http://schemas.microsoft.com/office/drawing/2014/main" id="{0D1240FF-5C1A-11B8-7FBE-2D26C3E8C412}"/>
-              </a:ext>
-            </a:extLst>
-          </p:cNvPr>
-          <p:cNvPicPr>
-            <a:picLocks noChangeAspect="1"/>
-          </p:cNvPicPr>
-          <p:nvPr/>
-        </p:nvPicPr>
-        <p:blipFill>
-          <a:blip r:embed="rId3">
+          <a:blip r:embed="rId2">
             <a:duotone>
               <a:prstClr val="black"/>
               <a:schemeClr val="tx2">
@@ -6358,76 +5326,12 @@
           </a:prstGeom>
         </p:spPr>
       </p:pic>
-      <p:sp>
-        <p:nvSpPr>
-          <p:cNvPr id="20" name="Retângulo: Cantos Arredondados 19">
-            <a:extLst>
-              <a:ext uri="{FF2B5EF4-FFF2-40B4-BE49-F238E27FC236}">
-                <a16:creationId xmlns:a16="http://schemas.microsoft.com/office/drawing/2014/main" id="{40240FA1-B7A7-E813-8C22-69D7182DF3AA}"/>
-              </a:ext>
-            </a:extLst>
-          </p:cNvPr>
-          <p:cNvSpPr/>
-          <p:nvPr/>
-        </p:nvSpPr>
-        <p:spPr>
-          <a:xfrm>
-            <a:off x="18878190" y="11075213"/>
-            <a:ext cx="2573924" cy="1602422"/>
-          </a:xfrm>
-          <a:prstGeom prst="roundRect">
-            <a:avLst/>
-          </a:prstGeom>
-          <a:solidFill>
-            <a:schemeClr val="bg1"/>
-          </a:solidFill>
-          <a:ln>
-            <a:noFill/>
-          </a:ln>
-          <a:effectLst>
-            <a:outerShdw blurRad="50800" dist="38100" dir="5400000" algn="t" rotWithShape="0">
-              <a:srgbClr val="05324B">
-                <a:alpha val="40000"/>
-              </a:srgbClr>
-            </a:outerShdw>
-          </a:effectLst>
-        </p:spPr>
-        <p:style>
-          <a:lnRef idx="2">
-            <a:schemeClr val="accent1">
-              <a:shade val="50000"/>
-            </a:schemeClr>
-          </a:lnRef>
-          <a:fillRef idx="1">
-            <a:schemeClr val="accent1"/>
-          </a:fillRef>
-          <a:effectRef idx="0">
-            <a:schemeClr val="accent1"/>
-          </a:effectRef>
-          <a:fontRef idx="minor">
-            <a:schemeClr val="lt1"/>
-          </a:fontRef>
-        </p:style>
-        <p:txBody>
-          <a:bodyPr rtlCol="0" anchor="ctr"/>
-          <a:lstStyle/>
-          <a:p>
-            <a:pPr algn="ctr"/>
-            <a:endParaRPr lang="pt-BR" sz="2400">
-              <a:solidFill>
-                <a:prstClr val="white"/>
-              </a:solidFill>
-              <a:latin typeface="Calibri" panose="020F0502020204030204"/>
-            </a:endParaRPr>
-          </a:p>
-        </p:txBody>
-      </p:sp>
       <p:grpSp>
         <p:nvGrpSpPr>
           <p:cNvPr id="23" name="Agrupar 22">
             <a:extLst>
               <a:ext uri="{FF2B5EF4-FFF2-40B4-BE49-F238E27FC236}">
-                <a16:creationId xmlns:a16="http://schemas.microsoft.com/office/drawing/2014/main" id="{A09D3632-15B3-345C-C36B-CF62E5D2A468}"/>
+                <a16:creationId xmlns:a16="http://schemas.microsoft.com/office/drawing/2014/main" id="{7C2F52E4-B050-882E-7E74-F7A685B0F9A3}"/>
               </a:ext>
             </a:extLst>
           </p:cNvPr>
@@ -6436,8 +5340,8 @@
         </p:nvGrpSpPr>
         <p:grpSpPr>
           <a:xfrm>
-            <a:off x="18878189" y="9925420"/>
-            <a:ext cx="13738802" cy="995739"/>
+            <a:off x="18698354" y="9925420"/>
+            <a:ext cx="14918545" cy="995739"/>
             <a:chOff x="18680926" y="9879347"/>
             <a:chExt cx="14002071" cy="1122481"/>
           </a:xfrm>
@@ -6447,7 +5351,7 @@
             <p:cNvPr id="6" name="Retângulo: Cantos Arredondados 5">
               <a:extLst>
                 <a:ext uri="{FF2B5EF4-FFF2-40B4-BE49-F238E27FC236}">
-                  <a16:creationId xmlns:a16="http://schemas.microsoft.com/office/drawing/2014/main" id="{DFA05216-39A3-EB78-4E66-F60F25625D04}"/>
+                  <a16:creationId xmlns:a16="http://schemas.microsoft.com/office/drawing/2014/main" id="{CD829ED4-59B7-69F0-9261-816B317B7B53}"/>
                 </a:ext>
               </a:extLst>
             </p:cNvPr>
@@ -6530,7 +5434,7 @@
             <p:cNvPr id="3" name="CaixaDeTexto 2">
               <a:extLst>
                 <a:ext uri="{FF2B5EF4-FFF2-40B4-BE49-F238E27FC236}">
-                  <a16:creationId xmlns:a16="http://schemas.microsoft.com/office/drawing/2014/main" id="{C07AB125-B69F-7FDD-2E77-CAA470AC80BC}"/>
+                  <a16:creationId xmlns:a16="http://schemas.microsoft.com/office/drawing/2014/main" id="{CE3DAE02-4715-EF2D-C172-F88153BB8F0D}"/>
                 </a:ext>
               </a:extLst>
             </p:cNvPr>
@@ -6540,7 +5444,7 @@
           <p:spPr>
             <a:xfrm>
               <a:off x="18891466" y="10005809"/>
-              <a:ext cx="8656648" cy="589818"/>
+              <a:ext cx="13791531" cy="589818"/>
             </a:xfrm>
             <a:prstGeom prst="rect">
               <a:avLst/>
@@ -6553,6 +5457,7 @@
             </a:bodyPr>
             <a:lstStyle/>
             <a:p>
+              <a:pPr algn="ctr"/>
               <a:r>
                 <a:rPr lang="pt-BR" sz="2800" b="1" dirty="0">
                   <a:solidFill>
@@ -6560,7 +5465,7 @@
                   </a:solidFill>
                   <a:latin typeface="Din"/>
                 </a:rPr>
-                <a:t>Sales Insights – Visão Executiva</a:t>
+                <a:t>Sales Insights – Análise por Canal e Região</a:t>
               </a:r>
             </a:p>
           </p:txBody>
@@ -6570,7 +5475,7 @@
             <p:cNvPr id="8" name="CaixaDeTexto 7">
               <a:extLst>
                 <a:ext uri="{FF2B5EF4-FFF2-40B4-BE49-F238E27FC236}">
-                  <a16:creationId xmlns:a16="http://schemas.microsoft.com/office/drawing/2014/main" id="{96F821C8-303F-6BF1-C75A-683B207F1CB5}"/>
+                  <a16:creationId xmlns:a16="http://schemas.microsoft.com/office/drawing/2014/main" id="{DF6A4ACD-3E7F-B6C4-2A6B-264DEEF83F35}"/>
                 </a:ext>
               </a:extLst>
             </p:cNvPr>
@@ -6580,7 +5485,7 @@
           <p:spPr>
             <a:xfrm>
               <a:off x="18891466" y="10581735"/>
-              <a:ext cx="8656648" cy="346952"/>
+              <a:ext cx="13791531" cy="346952"/>
             </a:xfrm>
             <a:prstGeom prst="rect">
               <a:avLst/>
@@ -6593,6 +5498,7 @@
             </a:bodyPr>
             <a:lstStyle/>
             <a:p>
+              <a:pPr algn="ctr"/>
               <a:r>
                 <a:rPr lang="pt-BR" sz="1400" dirty="0">
                   <a:solidFill>
@@ -6633,7 +5539,7 @@
           <p:cNvPr id="27" name="Retângulo: Cantos Arredondados 26">
             <a:extLst>
               <a:ext uri="{FF2B5EF4-FFF2-40B4-BE49-F238E27FC236}">
-                <a16:creationId xmlns:a16="http://schemas.microsoft.com/office/drawing/2014/main" id="{090ED756-B37B-1D10-EE0D-6EA816A0EDCC}"/>
+                <a16:creationId xmlns:a16="http://schemas.microsoft.com/office/drawing/2014/main" id="{2280FB4B-0FAE-D4C1-D815-7B1019BB79EC}"/>
               </a:ext>
             </a:extLst>
           </p:cNvPr>
@@ -6642,8 +5548,8 @@
         </p:nvSpPr>
         <p:spPr>
           <a:xfrm>
-            <a:off x="18878190" y="12870836"/>
-            <a:ext cx="7145924" cy="2825929"/>
+            <a:off x="18698354" y="12748980"/>
+            <a:ext cx="7387446" cy="3037120"/>
           </a:xfrm>
           <a:prstGeom prst="roundRect">
             <a:avLst>
@@ -6696,10 +5602,10 @@
       </p:sp>
       <p:sp>
         <p:nvSpPr>
-          <p:cNvPr id="49" name="Retângulo: Cantos Arredondados 48">
+          <p:cNvPr id="62" name="Retângulo: Cantos Arredondados 61">
             <a:extLst>
               <a:ext uri="{FF2B5EF4-FFF2-40B4-BE49-F238E27FC236}">
-                <a16:creationId xmlns:a16="http://schemas.microsoft.com/office/drawing/2014/main" id="{B5E4D67C-FFB6-A3C7-BE94-8F31790C061F}"/>
+                <a16:creationId xmlns:a16="http://schemas.microsoft.com/office/drawing/2014/main" id="{8C763677-5DA4-B22F-217A-52AB0C379F53}"/>
               </a:ext>
             </a:extLst>
           </p:cNvPr>
@@ -6708,8 +5614,330 @@
         </p:nvSpPr>
         <p:spPr>
           <a:xfrm>
-            <a:off x="26304730" y="12870836"/>
-            <a:ext cx="7145924" cy="2825929"/>
+            <a:off x="20836836" y="11068944"/>
+            <a:ext cx="2573924" cy="1519713"/>
+          </a:xfrm>
+          <a:prstGeom prst="roundRect">
+            <a:avLst/>
+          </a:prstGeom>
+          <a:solidFill>
+            <a:schemeClr val="bg1"/>
+          </a:solidFill>
+          <a:ln>
+            <a:noFill/>
+          </a:ln>
+          <a:effectLst>
+            <a:outerShdw blurRad="50800" dist="38100" dir="5400000" algn="t" rotWithShape="0">
+              <a:srgbClr val="05324B">
+                <a:alpha val="40000"/>
+              </a:srgbClr>
+            </a:outerShdw>
+          </a:effectLst>
+        </p:spPr>
+        <p:style>
+          <a:lnRef idx="2">
+            <a:schemeClr val="accent1">
+              <a:shade val="50000"/>
+            </a:schemeClr>
+          </a:lnRef>
+          <a:fillRef idx="1">
+            <a:schemeClr val="accent1"/>
+          </a:fillRef>
+          <a:effectRef idx="0">
+            <a:schemeClr val="accent1"/>
+          </a:effectRef>
+          <a:fontRef idx="minor">
+            <a:schemeClr val="lt1"/>
+          </a:fontRef>
+        </p:style>
+        <p:txBody>
+          <a:bodyPr rtlCol="0" anchor="ctr"/>
+          <a:lstStyle/>
+          <a:p>
+            <a:pPr algn="ctr"/>
+            <a:endParaRPr lang="pt-BR" sz="2400">
+              <a:solidFill>
+                <a:prstClr val="white"/>
+              </a:solidFill>
+              <a:latin typeface="Calibri" panose="020F0502020204030204"/>
+            </a:endParaRPr>
+          </a:p>
+        </p:txBody>
+      </p:sp>
+      <p:sp>
+        <p:nvSpPr>
+          <p:cNvPr id="63" name="Retângulo: Cantos Arredondados 62">
+            <a:extLst>
+              <a:ext uri="{FF2B5EF4-FFF2-40B4-BE49-F238E27FC236}">
+                <a16:creationId xmlns:a16="http://schemas.microsoft.com/office/drawing/2014/main" id="{9DABE012-C992-6CC0-0D9E-FF292C66EC94}"/>
+              </a:ext>
+            </a:extLst>
+          </p:cNvPr>
+          <p:cNvSpPr/>
+          <p:nvPr/>
+        </p:nvSpPr>
+        <p:spPr>
+          <a:xfrm>
+            <a:off x="23526055" y="11068944"/>
+            <a:ext cx="2573924" cy="1519713"/>
+          </a:xfrm>
+          <a:prstGeom prst="roundRect">
+            <a:avLst/>
+          </a:prstGeom>
+          <a:solidFill>
+            <a:schemeClr val="bg1"/>
+          </a:solidFill>
+          <a:ln>
+            <a:noFill/>
+          </a:ln>
+          <a:effectLst>
+            <a:outerShdw blurRad="50800" dist="38100" dir="5400000" algn="t" rotWithShape="0">
+              <a:srgbClr val="05324B">
+                <a:alpha val="40000"/>
+              </a:srgbClr>
+            </a:outerShdw>
+          </a:effectLst>
+        </p:spPr>
+        <p:style>
+          <a:lnRef idx="2">
+            <a:schemeClr val="accent1">
+              <a:shade val="50000"/>
+            </a:schemeClr>
+          </a:lnRef>
+          <a:fillRef idx="1">
+            <a:schemeClr val="accent1"/>
+          </a:fillRef>
+          <a:effectRef idx="0">
+            <a:schemeClr val="accent1"/>
+          </a:effectRef>
+          <a:fontRef idx="minor">
+            <a:schemeClr val="lt1"/>
+          </a:fontRef>
+        </p:style>
+        <p:txBody>
+          <a:bodyPr rtlCol="0" anchor="ctr"/>
+          <a:lstStyle/>
+          <a:p>
+            <a:pPr algn="ctr"/>
+            <a:endParaRPr lang="pt-BR" sz="2400">
+              <a:solidFill>
+                <a:prstClr val="white"/>
+              </a:solidFill>
+              <a:latin typeface="Calibri" panose="020F0502020204030204"/>
+            </a:endParaRPr>
+          </a:p>
+        </p:txBody>
+      </p:sp>
+      <p:sp>
+        <p:nvSpPr>
+          <p:cNvPr id="64" name="Retângulo: Cantos Arredondados 63">
+            <a:extLst>
+              <a:ext uri="{FF2B5EF4-FFF2-40B4-BE49-F238E27FC236}">
+                <a16:creationId xmlns:a16="http://schemas.microsoft.com/office/drawing/2014/main" id="{72AF9DCA-D8E4-C2EF-2A3D-F2D2208DEFC4}"/>
+              </a:ext>
+            </a:extLst>
+          </p:cNvPr>
+          <p:cNvSpPr/>
+          <p:nvPr/>
+        </p:nvSpPr>
+        <p:spPr>
+          <a:xfrm>
+            <a:off x="26215274" y="11068944"/>
+            <a:ext cx="2573924" cy="1519713"/>
+          </a:xfrm>
+          <a:prstGeom prst="roundRect">
+            <a:avLst/>
+          </a:prstGeom>
+          <a:solidFill>
+            <a:schemeClr val="bg1"/>
+          </a:solidFill>
+          <a:ln>
+            <a:noFill/>
+          </a:ln>
+          <a:effectLst>
+            <a:outerShdw blurRad="50800" dist="38100" dir="5400000" algn="t" rotWithShape="0">
+              <a:srgbClr val="05324B">
+                <a:alpha val="40000"/>
+              </a:srgbClr>
+            </a:outerShdw>
+          </a:effectLst>
+        </p:spPr>
+        <p:style>
+          <a:lnRef idx="2">
+            <a:schemeClr val="accent1">
+              <a:shade val="50000"/>
+            </a:schemeClr>
+          </a:lnRef>
+          <a:fillRef idx="1">
+            <a:schemeClr val="accent1"/>
+          </a:fillRef>
+          <a:effectRef idx="0">
+            <a:schemeClr val="accent1"/>
+          </a:effectRef>
+          <a:fontRef idx="minor">
+            <a:schemeClr val="lt1"/>
+          </a:fontRef>
+        </p:style>
+        <p:txBody>
+          <a:bodyPr rtlCol="0" anchor="ctr"/>
+          <a:lstStyle/>
+          <a:p>
+            <a:pPr algn="ctr"/>
+            <a:endParaRPr lang="pt-BR" sz="2400">
+              <a:solidFill>
+                <a:prstClr val="white"/>
+              </a:solidFill>
+              <a:latin typeface="Calibri" panose="020F0502020204030204"/>
+            </a:endParaRPr>
+          </a:p>
+        </p:txBody>
+      </p:sp>
+      <p:pic>
+        <p:nvPicPr>
+          <p:cNvPr id="66" name="Imagem 65" descr="Ícone&#10;&#10;O conteúdo gerado por IA pode estar incorreto.">
+            <a:extLst>
+              <a:ext uri="{FF2B5EF4-FFF2-40B4-BE49-F238E27FC236}">
+                <a16:creationId xmlns:a16="http://schemas.microsoft.com/office/drawing/2014/main" id="{FCBCF875-51A5-BE5E-BB26-8E959C5922AB}"/>
+              </a:ext>
+            </a:extLst>
+          </p:cNvPr>
+          <p:cNvPicPr>
+            <a:picLocks noChangeAspect="1"/>
+          </p:cNvPicPr>
+          <p:nvPr/>
+        </p:nvPicPr>
+        <p:blipFill>
+          <a:blip r:embed="rId3">
+            <a:duotone>
+              <a:prstClr val="black"/>
+              <a:schemeClr val="tx2">
+                <a:tint val="45000"/>
+                <a:satMod val="400000"/>
+              </a:schemeClr>
+            </a:duotone>
+            <a:extLst>
+              <a:ext uri="{28A0092B-C50C-407E-A947-70E740481C1C}">
+                <a14:useLocalDpi xmlns:a14="http://schemas.microsoft.com/office/drawing/2010/main" val="0"/>
+              </a:ext>
+            </a:extLst>
+          </a:blip>
+          <a:stretch>
+            <a:fillRect/>
+          </a:stretch>
+        </p:blipFill>
+        <p:spPr>
+          <a:xfrm>
+            <a:off x="17820139" y="13678050"/>
+            <a:ext cx="532661" cy="532661"/>
+          </a:xfrm>
+          <a:prstGeom prst="rect">
+            <a:avLst/>
+          </a:prstGeom>
+        </p:spPr>
+      </p:pic>
+      <p:pic>
+        <p:nvPicPr>
+          <p:cNvPr id="67" name="Imagem 66" descr="Ícone&#10;&#10;O conteúdo gerado por IA pode estar incorreto.">
+            <a:extLst>
+              <a:ext uri="{FF2B5EF4-FFF2-40B4-BE49-F238E27FC236}">
+                <a16:creationId xmlns:a16="http://schemas.microsoft.com/office/drawing/2014/main" id="{9005CB5C-5EBD-91A3-C867-C01C7EC3E148}"/>
+              </a:ext>
+            </a:extLst>
+          </p:cNvPr>
+          <p:cNvPicPr>
+            <a:picLocks noChangeAspect="1"/>
+          </p:cNvPicPr>
+          <p:nvPr/>
+        </p:nvPicPr>
+        <p:blipFill>
+          <a:blip r:embed="rId4">
+            <a:duotone>
+              <a:prstClr val="black"/>
+              <a:schemeClr val="tx2">
+                <a:tint val="45000"/>
+                <a:satMod val="400000"/>
+              </a:schemeClr>
+            </a:duotone>
+            <a:extLst>
+              <a:ext uri="{28A0092B-C50C-407E-A947-70E740481C1C}">
+                <a14:useLocalDpi xmlns:a14="http://schemas.microsoft.com/office/drawing/2010/main" val="0"/>
+              </a:ext>
+            </a:extLst>
+          </a:blip>
+          <a:stretch>
+            <a:fillRect/>
+          </a:stretch>
+        </p:blipFill>
+        <p:spPr>
+          <a:xfrm>
+            <a:off x="17820140" y="11586643"/>
+            <a:ext cx="532661" cy="532661"/>
+          </a:xfrm>
+          <a:prstGeom prst="rect">
+            <a:avLst/>
+          </a:prstGeom>
+        </p:spPr>
+      </p:pic>
+      <p:pic>
+        <p:nvPicPr>
+          <p:cNvPr id="68" name="Imagem 67" descr="Ícone&#10;&#10;O conteúdo gerado por IA pode estar incorreto.">
+            <a:extLst>
+              <a:ext uri="{FF2B5EF4-FFF2-40B4-BE49-F238E27FC236}">
+                <a16:creationId xmlns:a16="http://schemas.microsoft.com/office/drawing/2014/main" id="{4FCB1D91-0D44-C435-BB2D-883767A1F377}"/>
+              </a:ext>
+            </a:extLst>
+          </p:cNvPr>
+          <p:cNvPicPr>
+            <a:picLocks noChangeAspect="1"/>
+          </p:cNvPicPr>
+          <p:nvPr/>
+        </p:nvPicPr>
+        <p:blipFill>
+          <a:blip r:embed="rId5">
+            <a:extLst>
+              <a:ext uri="{28A0092B-C50C-407E-A947-70E740481C1C}">
+                <a14:useLocalDpi xmlns:a14="http://schemas.microsoft.com/office/drawing/2010/main" val="0"/>
+              </a:ext>
+            </a:extLst>
+          </a:blip>
+          <a:stretch>
+            <a:fillRect/>
+          </a:stretch>
+        </p:blipFill>
+        <p:spPr>
+          <a:xfrm>
+            <a:off x="17820140" y="12646861"/>
+            <a:ext cx="532660" cy="532660"/>
+          </a:xfrm>
+          <a:prstGeom prst="rect">
+            <a:avLst/>
+          </a:prstGeom>
+          <a:effectLst>
+            <a:glow rad="63500">
+              <a:schemeClr val="accent1">
+                <a:satMod val="175000"/>
+                <a:alpha val="40000"/>
+              </a:schemeClr>
+            </a:glow>
+          </a:effectLst>
+        </p:spPr>
+      </p:pic>
+      <p:sp>
+        <p:nvSpPr>
+          <p:cNvPr id="10" name="Retângulo: Cantos Arredondados 9">
+            <a:extLst>
+              <a:ext uri="{FF2B5EF4-FFF2-40B4-BE49-F238E27FC236}">
+                <a16:creationId xmlns:a16="http://schemas.microsoft.com/office/drawing/2014/main" id="{2BDDE4CC-970F-39EC-CE7F-7ED9790743F0}"/>
+              </a:ext>
+            </a:extLst>
+          </p:cNvPr>
+          <p:cNvSpPr/>
+          <p:nvPr/>
+        </p:nvSpPr>
+        <p:spPr>
+          <a:xfrm>
+            <a:off x="18712532" y="15935112"/>
+            <a:ext cx="14890187" cy="3037120"/>
           </a:xfrm>
           <a:prstGeom prst="roundRect">
             <a:avLst>
@@ -6762,10 +5990,10 @@
       </p:sp>
       <p:sp>
         <p:nvSpPr>
-          <p:cNvPr id="50" name="Retângulo: Cantos Arredondados 49">
+          <p:cNvPr id="11" name="Retângulo: Cantos Arredondados 10">
             <a:extLst>
               <a:ext uri="{FF2B5EF4-FFF2-40B4-BE49-F238E27FC236}">
-                <a16:creationId xmlns:a16="http://schemas.microsoft.com/office/drawing/2014/main" id="{6BC3BC77-4ECC-E3F1-40F0-6AFA809963D3}"/>
+                <a16:creationId xmlns:a16="http://schemas.microsoft.com/office/drawing/2014/main" id="{16C27F2C-5D4F-53D0-2066-78C66A8AB731}"/>
               </a:ext>
             </a:extLst>
           </p:cNvPr>
@@ -6774,8 +6002,8 @@
         </p:nvSpPr>
         <p:spPr>
           <a:xfrm>
-            <a:off x="18878190" y="15870393"/>
-            <a:ext cx="7145924" cy="2825929"/>
+            <a:off x="26215274" y="12748980"/>
+            <a:ext cx="7387446" cy="3037120"/>
           </a:xfrm>
           <a:prstGeom prst="roundRect">
             <a:avLst>
@@ -6826,12 +6054,55 @@
           </a:p>
         </p:txBody>
       </p:sp>
-      <p:sp>
-        <p:nvSpPr>
-          <p:cNvPr id="51" name="Retângulo: Cantos Arredondados 50">
+      <p:pic>
+        <p:nvPicPr>
+          <p:cNvPr id="21" name="Imagem 20" descr="Ícone&#10;&#10;O conteúdo gerado por IA pode estar incorreto.">
             <a:extLst>
               <a:ext uri="{FF2B5EF4-FFF2-40B4-BE49-F238E27FC236}">
-                <a16:creationId xmlns:a16="http://schemas.microsoft.com/office/drawing/2014/main" id="{BF912804-9512-CDB0-9E33-62F448A97F4C}"/>
+                <a16:creationId xmlns:a16="http://schemas.microsoft.com/office/drawing/2014/main" id="{C45AA47B-96C9-F4A3-64F1-C8AB67B5A520}"/>
+              </a:ext>
+            </a:extLst>
+          </p:cNvPr>
+          <p:cNvPicPr>
+            <a:picLocks noChangeAspect="1"/>
+          </p:cNvPicPr>
+          <p:nvPr/>
+        </p:nvPicPr>
+        <p:blipFill>
+          <a:blip r:embed="rId6">
+            <a:duotone>
+              <a:prstClr val="black"/>
+              <a:schemeClr val="tx2">
+                <a:tint val="45000"/>
+                <a:satMod val="400000"/>
+              </a:schemeClr>
+            </a:duotone>
+            <a:extLst>
+              <a:ext uri="{28A0092B-C50C-407E-A947-70E740481C1C}">
+                <a14:useLocalDpi xmlns:a14="http://schemas.microsoft.com/office/drawing/2010/main" val="0"/>
+              </a:ext>
+            </a:extLst>
+          </a:blip>
+          <a:stretch>
+            <a:fillRect/>
+          </a:stretch>
+        </p:blipFill>
+        <p:spPr>
+          <a:xfrm>
+            <a:off x="32714027" y="10066769"/>
+            <a:ext cx="713039" cy="713039"/>
+          </a:xfrm>
+          <a:prstGeom prst="rect">
+            <a:avLst/>
+          </a:prstGeom>
+        </p:spPr>
+      </p:pic>
+      <p:sp>
+        <p:nvSpPr>
+          <p:cNvPr id="2" name="Retângulo: Cantos Arredondados 1">
+            <a:extLst>
+              <a:ext uri="{FF2B5EF4-FFF2-40B4-BE49-F238E27FC236}">
+                <a16:creationId xmlns:a16="http://schemas.microsoft.com/office/drawing/2014/main" id="{CCB16271-11BF-4E42-4F20-9BFFD7B27640}"/>
               </a:ext>
             </a:extLst>
           </p:cNvPr>
@@ -6840,74 +6111,8 @@
         </p:nvSpPr>
         <p:spPr>
           <a:xfrm>
-            <a:off x="26304730" y="15870393"/>
-            <a:ext cx="7145924" cy="2825929"/>
-          </a:xfrm>
-          <a:prstGeom prst="roundRect">
-            <a:avLst>
-              <a:gd name="adj" fmla="val 5412"/>
-            </a:avLst>
-          </a:prstGeom>
-          <a:solidFill>
-            <a:schemeClr val="bg1"/>
-          </a:solidFill>
-          <a:ln>
-            <a:noFill/>
-          </a:ln>
-          <a:effectLst>
-            <a:outerShdw blurRad="50800" dist="38100" dir="5400000" algn="t" rotWithShape="0">
-              <a:srgbClr val="05324B">
-                <a:alpha val="40000"/>
-              </a:srgbClr>
-            </a:outerShdw>
-          </a:effectLst>
-        </p:spPr>
-        <p:style>
-          <a:lnRef idx="2">
-            <a:schemeClr val="accent1">
-              <a:shade val="50000"/>
-            </a:schemeClr>
-          </a:lnRef>
-          <a:fillRef idx="1">
-            <a:schemeClr val="accent1"/>
-          </a:fillRef>
-          <a:effectRef idx="0">
-            <a:schemeClr val="accent1"/>
-          </a:effectRef>
-          <a:fontRef idx="minor">
-            <a:schemeClr val="lt1"/>
-          </a:fontRef>
-        </p:style>
-        <p:txBody>
-          <a:bodyPr rtlCol="0" anchor="ctr"/>
-          <a:lstStyle/>
-          <a:p>
-            <a:pPr algn="ctr"/>
-            <a:endParaRPr lang="pt-BR" sz="2400" dirty="0">
-              <a:solidFill>
-                <a:prstClr val="white"/>
-              </a:solidFill>
-              <a:latin typeface="Calibri" panose="020F0502020204030204"/>
-            </a:endParaRPr>
-          </a:p>
-        </p:txBody>
-      </p:sp>
-      <p:sp>
-        <p:nvSpPr>
-          <p:cNvPr id="62" name="Retângulo: Cantos Arredondados 61">
-            <a:extLst>
-              <a:ext uri="{FF2B5EF4-FFF2-40B4-BE49-F238E27FC236}">
-                <a16:creationId xmlns:a16="http://schemas.microsoft.com/office/drawing/2014/main" id="{FE025F01-E482-1108-7E4F-FCFED138FBF3}"/>
-              </a:ext>
-            </a:extLst>
-          </p:cNvPr>
-          <p:cNvSpPr/>
-          <p:nvPr/>
-        </p:nvSpPr>
-        <p:spPr>
-          <a:xfrm>
-            <a:off x="21877825" y="11075213"/>
-            <a:ext cx="2573924" cy="1602422"/>
+            <a:off x="28904493" y="11068944"/>
+            <a:ext cx="2573924" cy="1519713"/>
           </a:xfrm>
           <a:prstGeom prst="roundRect">
             <a:avLst/>
@@ -6956,368 +6161,10 @@
           </a:p>
         </p:txBody>
       </p:sp>
-      <p:sp>
-        <p:nvSpPr>
-          <p:cNvPr id="63" name="Retângulo: Cantos Arredondados 62">
-            <a:extLst>
-              <a:ext uri="{FF2B5EF4-FFF2-40B4-BE49-F238E27FC236}">
-                <a16:creationId xmlns:a16="http://schemas.microsoft.com/office/drawing/2014/main" id="{A0F78AA2-BA44-923D-3D67-BA7205AAE834}"/>
-              </a:ext>
-            </a:extLst>
-          </p:cNvPr>
-          <p:cNvSpPr/>
-          <p:nvPr/>
-        </p:nvSpPr>
-        <p:spPr>
-          <a:xfrm>
-            <a:off x="24877460" y="11075213"/>
-            <a:ext cx="2573924" cy="1602422"/>
-          </a:xfrm>
-          <a:prstGeom prst="roundRect">
-            <a:avLst/>
-          </a:prstGeom>
-          <a:solidFill>
-            <a:schemeClr val="bg1"/>
-          </a:solidFill>
-          <a:ln>
-            <a:noFill/>
-          </a:ln>
-          <a:effectLst>
-            <a:outerShdw blurRad="50800" dist="38100" dir="5400000" algn="t" rotWithShape="0">
-              <a:srgbClr val="05324B">
-                <a:alpha val="40000"/>
-              </a:srgbClr>
-            </a:outerShdw>
-          </a:effectLst>
-        </p:spPr>
-        <p:style>
-          <a:lnRef idx="2">
-            <a:schemeClr val="accent1">
-              <a:shade val="50000"/>
-            </a:schemeClr>
-          </a:lnRef>
-          <a:fillRef idx="1">
-            <a:schemeClr val="accent1"/>
-          </a:fillRef>
-          <a:effectRef idx="0">
-            <a:schemeClr val="accent1"/>
-          </a:effectRef>
-          <a:fontRef idx="minor">
-            <a:schemeClr val="lt1"/>
-          </a:fontRef>
-        </p:style>
-        <p:txBody>
-          <a:bodyPr rtlCol="0" anchor="ctr"/>
-          <a:lstStyle/>
-          <a:p>
-            <a:pPr algn="ctr"/>
-            <a:endParaRPr lang="pt-BR" sz="2400">
-              <a:solidFill>
-                <a:prstClr val="white"/>
-              </a:solidFill>
-              <a:latin typeface="Calibri" panose="020F0502020204030204"/>
-            </a:endParaRPr>
-          </a:p>
-        </p:txBody>
-      </p:sp>
-      <p:sp>
-        <p:nvSpPr>
-          <p:cNvPr id="64" name="Retângulo: Cantos Arredondados 63">
-            <a:extLst>
-              <a:ext uri="{FF2B5EF4-FFF2-40B4-BE49-F238E27FC236}">
-                <a16:creationId xmlns:a16="http://schemas.microsoft.com/office/drawing/2014/main" id="{F89FB353-190C-E309-51E7-8535E89FDCCD}"/>
-              </a:ext>
-            </a:extLst>
-          </p:cNvPr>
-          <p:cNvSpPr/>
-          <p:nvPr/>
-        </p:nvSpPr>
-        <p:spPr>
-          <a:xfrm>
-            <a:off x="27877095" y="11075213"/>
-            <a:ext cx="2573924" cy="1602422"/>
-          </a:xfrm>
-          <a:prstGeom prst="roundRect">
-            <a:avLst/>
-          </a:prstGeom>
-          <a:solidFill>
-            <a:schemeClr val="bg1"/>
-          </a:solidFill>
-          <a:ln>
-            <a:noFill/>
-          </a:ln>
-          <a:effectLst>
-            <a:outerShdw blurRad="50800" dist="38100" dir="5400000" algn="t" rotWithShape="0">
-              <a:srgbClr val="05324B">
-                <a:alpha val="40000"/>
-              </a:srgbClr>
-            </a:outerShdw>
-          </a:effectLst>
-        </p:spPr>
-        <p:style>
-          <a:lnRef idx="2">
-            <a:schemeClr val="accent1">
-              <a:shade val="50000"/>
-            </a:schemeClr>
-          </a:lnRef>
-          <a:fillRef idx="1">
-            <a:schemeClr val="accent1"/>
-          </a:fillRef>
-          <a:effectRef idx="0">
-            <a:schemeClr val="accent1"/>
-          </a:effectRef>
-          <a:fontRef idx="minor">
-            <a:schemeClr val="lt1"/>
-          </a:fontRef>
-        </p:style>
-        <p:txBody>
-          <a:bodyPr rtlCol="0" anchor="ctr"/>
-          <a:lstStyle/>
-          <a:p>
-            <a:pPr algn="ctr"/>
-            <a:endParaRPr lang="pt-BR" sz="2400">
-              <a:solidFill>
-                <a:prstClr val="white"/>
-              </a:solidFill>
-              <a:latin typeface="Calibri" panose="020F0502020204030204"/>
-            </a:endParaRPr>
-          </a:p>
-        </p:txBody>
-      </p:sp>
-      <p:sp>
-        <p:nvSpPr>
-          <p:cNvPr id="65" name="Retângulo: Cantos Arredondados 64">
-            <a:extLst>
-              <a:ext uri="{FF2B5EF4-FFF2-40B4-BE49-F238E27FC236}">
-                <a16:creationId xmlns:a16="http://schemas.microsoft.com/office/drawing/2014/main" id="{2B3BBCC7-28DE-87C2-4900-0F0CD6E88ECD}"/>
-              </a:ext>
-            </a:extLst>
-          </p:cNvPr>
-          <p:cNvSpPr/>
-          <p:nvPr/>
-        </p:nvSpPr>
-        <p:spPr>
-          <a:xfrm>
-            <a:off x="30876730" y="11075213"/>
-            <a:ext cx="2573924" cy="1602422"/>
-          </a:xfrm>
-          <a:prstGeom prst="roundRect">
-            <a:avLst/>
-          </a:prstGeom>
-          <a:solidFill>
-            <a:schemeClr val="bg1"/>
-          </a:solidFill>
-          <a:ln>
-            <a:noFill/>
-          </a:ln>
-          <a:effectLst>
-            <a:outerShdw blurRad="50800" dist="38100" dir="5400000" algn="t" rotWithShape="0">
-              <a:srgbClr val="05324B">
-                <a:alpha val="40000"/>
-              </a:srgbClr>
-            </a:outerShdw>
-          </a:effectLst>
-        </p:spPr>
-        <p:style>
-          <a:lnRef idx="2">
-            <a:schemeClr val="accent1">
-              <a:shade val="50000"/>
-            </a:schemeClr>
-          </a:lnRef>
-          <a:fillRef idx="1">
-            <a:schemeClr val="accent1"/>
-          </a:fillRef>
-          <a:effectRef idx="0">
-            <a:schemeClr val="accent1"/>
-          </a:effectRef>
-          <a:fontRef idx="minor">
-            <a:schemeClr val="lt1"/>
-          </a:fontRef>
-        </p:style>
-        <p:txBody>
-          <a:bodyPr rtlCol="0" anchor="ctr"/>
-          <a:lstStyle/>
-          <a:p>
-            <a:pPr algn="ctr"/>
-            <a:endParaRPr lang="pt-BR" sz="2400">
-              <a:solidFill>
-                <a:prstClr val="white"/>
-              </a:solidFill>
-              <a:latin typeface="Calibri" panose="020F0502020204030204"/>
-            </a:endParaRPr>
-          </a:p>
-        </p:txBody>
-      </p:sp>
-      <p:pic>
-        <p:nvPicPr>
-          <p:cNvPr id="66" name="Imagem 65" descr="Ícone&#10;&#10;O conteúdo gerado por IA pode estar incorreto.">
-            <a:extLst>
-              <a:ext uri="{FF2B5EF4-FFF2-40B4-BE49-F238E27FC236}">
-                <a16:creationId xmlns:a16="http://schemas.microsoft.com/office/drawing/2014/main" id="{EA92C84B-C622-1325-8624-A6C2D91BF80A}"/>
-              </a:ext>
-            </a:extLst>
-          </p:cNvPr>
-          <p:cNvPicPr>
-            <a:picLocks noChangeAspect="1"/>
-          </p:cNvPicPr>
-          <p:nvPr/>
-        </p:nvPicPr>
-        <p:blipFill>
-          <a:blip r:embed="rId4">
-            <a:duotone>
-              <a:prstClr val="black"/>
-              <a:schemeClr val="tx2">
-                <a:tint val="45000"/>
-                <a:satMod val="400000"/>
-              </a:schemeClr>
-            </a:duotone>
-            <a:extLst>
-              <a:ext uri="{28A0092B-C50C-407E-A947-70E740481C1C}">
-                <a14:useLocalDpi xmlns:a14="http://schemas.microsoft.com/office/drawing/2010/main" val="0"/>
-              </a:ext>
-            </a:extLst>
-          </a:blip>
-          <a:stretch>
-            <a:fillRect/>
-          </a:stretch>
-        </p:blipFill>
-        <p:spPr>
-          <a:xfrm>
-            <a:off x="17820139" y="13678050"/>
-            <a:ext cx="532661" cy="532661"/>
-          </a:xfrm>
-          <a:prstGeom prst="rect">
-            <a:avLst/>
-          </a:prstGeom>
-        </p:spPr>
-      </p:pic>
-      <p:pic>
-        <p:nvPicPr>
-          <p:cNvPr id="67" name="Imagem 66" descr="Ícone&#10;&#10;O conteúdo gerado por IA pode estar incorreto.">
-            <a:extLst>
-              <a:ext uri="{FF2B5EF4-FFF2-40B4-BE49-F238E27FC236}">
-                <a16:creationId xmlns:a16="http://schemas.microsoft.com/office/drawing/2014/main" id="{EE6D1A81-3769-4146-1B1B-FC8E1E95A2C1}"/>
-              </a:ext>
-            </a:extLst>
-          </p:cNvPr>
-          <p:cNvPicPr>
-            <a:picLocks noChangeAspect="1"/>
-          </p:cNvPicPr>
-          <p:nvPr/>
-        </p:nvPicPr>
-        <p:blipFill>
-          <a:blip r:embed="rId5">
-            <a:duotone>
-              <a:prstClr val="black"/>
-              <a:schemeClr val="tx2">
-                <a:tint val="45000"/>
-                <a:satMod val="400000"/>
-              </a:schemeClr>
-            </a:duotone>
-            <a:extLst>
-              <a:ext uri="{28A0092B-C50C-407E-A947-70E740481C1C}">
-                <a14:useLocalDpi xmlns:a14="http://schemas.microsoft.com/office/drawing/2010/main" val="0"/>
-              </a:ext>
-            </a:extLst>
-          </a:blip>
-          <a:stretch>
-            <a:fillRect/>
-          </a:stretch>
-        </p:blipFill>
-        <p:spPr>
-          <a:xfrm>
-            <a:off x="17820140" y="11586643"/>
-            <a:ext cx="532661" cy="532661"/>
-          </a:xfrm>
-          <a:prstGeom prst="rect">
-            <a:avLst/>
-          </a:prstGeom>
-        </p:spPr>
-      </p:pic>
-      <p:pic>
-        <p:nvPicPr>
-          <p:cNvPr id="68" name="Imagem 67" descr="Ícone&#10;&#10;O conteúdo gerado por IA pode estar incorreto.">
-            <a:extLst>
-              <a:ext uri="{FF2B5EF4-FFF2-40B4-BE49-F238E27FC236}">
-                <a16:creationId xmlns:a16="http://schemas.microsoft.com/office/drawing/2014/main" id="{EDB62D85-6660-BD25-1B38-EECEA3372EEC}"/>
-              </a:ext>
-            </a:extLst>
-          </p:cNvPr>
-          <p:cNvPicPr>
-            <a:picLocks noChangeAspect="1"/>
-          </p:cNvPicPr>
-          <p:nvPr/>
-        </p:nvPicPr>
-        <p:blipFill>
-          <a:blip r:embed="rId6">
-            <a:extLst>
-              <a:ext uri="{28A0092B-C50C-407E-A947-70E740481C1C}">
-                <a14:useLocalDpi xmlns:a14="http://schemas.microsoft.com/office/drawing/2010/main" val="0"/>
-              </a:ext>
-            </a:extLst>
-          </a:blip>
-          <a:stretch>
-            <a:fillRect/>
-          </a:stretch>
-        </p:blipFill>
-        <p:spPr>
-          <a:xfrm>
-            <a:off x="17820140" y="12646861"/>
-            <a:ext cx="532660" cy="532660"/>
-          </a:xfrm>
-          <a:prstGeom prst="rect">
-            <a:avLst/>
-          </a:prstGeom>
-          <a:effectLst>
-            <a:glow rad="63500">
-              <a:schemeClr val="accent1">
-                <a:satMod val="175000"/>
-                <a:alpha val="40000"/>
-              </a:schemeClr>
-            </a:glow>
-          </a:effectLst>
-        </p:spPr>
-      </p:pic>
-      <p:pic>
-        <p:nvPicPr>
-          <p:cNvPr id="2" name="Imagem 1" descr="Logotipo, nome da empresa&#10;&#10;O conteúdo gerado por IA pode estar incorreto.">
-            <a:extLst>
-              <a:ext uri="{FF2B5EF4-FFF2-40B4-BE49-F238E27FC236}">
-                <a16:creationId xmlns:a16="http://schemas.microsoft.com/office/drawing/2014/main" id="{78A92BC1-A066-B0C1-F401-166D750B9C56}"/>
-              </a:ext>
-            </a:extLst>
-          </p:cNvPr>
-          <p:cNvPicPr>
-            <a:picLocks noChangeAspect="1"/>
-          </p:cNvPicPr>
-          <p:nvPr/>
-        </p:nvPicPr>
-        <p:blipFill>
-          <a:blip r:embed="rId7">
-            <a:extLst>
-              <a:ext uri="{28A0092B-C50C-407E-A947-70E740481C1C}">
-                <a14:useLocalDpi xmlns:a14="http://schemas.microsoft.com/office/drawing/2010/main" val="0"/>
-              </a:ext>
-            </a:extLst>
-          </a:blip>
-          <a:stretch>
-            <a:fillRect/>
-          </a:stretch>
-        </p:blipFill>
-        <p:spPr>
-          <a:xfrm>
-            <a:off x="17670283" y="17827977"/>
-            <a:ext cx="887870" cy="810289"/>
-          </a:xfrm>
-          <a:prstGeom prst="rect">
-            <a:avLst/>
-          </a:prstGeom>
-        </p:spPr>
-      </p:pic>
     </p:spTree>
     <p:extLst>
       <p:ext uri="{BB962C8B-B14F-4D97-AF65-F5344CB8AC3E}">
-        <p14:creationId xmlns:p14="http://schemas.microsoft.com/office/powerpoint/2010/main" val="3125794831"/>
+        <p14:creationId xmlns:p14="http://schemas.microsoft.com/office/powerpoint/2010/main" val="438492065"/>
       </p:ext>
     </p:extLst>
   </p:cSld>
@@ -7327,7 +6174,7 @@
 </p:sld>
 </file>
 
-<file path=ppt/slides/slide5.xml><?xml version="1.0" encoding="utf-8"?>
+<file path=ppt/slides/slide4.xml><?xml version="1.0" encoding="utf-8"?>
 <p:sld xmlns:a="http://schemas.openxmlformats.org/drawingml/2006/main" xmlns:r="http://schemas.openxmlformats.org/officeDocument/2006/relationships" xmlns:p="http://schemas.openxmlformats.org/presentationml/2006/main">
   <p:cSld>
     <p:spTree>
@@ -8536,7 +7383,7 @@
 </p:sld>
 </file>
 
-<file path=ppt/slides/slide6.xml><?xml version="1.0" encoding="utf-8"?>
+<file path=ppt/slides/slide5.xml><?xml version="1.0" encoding="utf-8"?>
 <p:sld xmlns:a="http://schemas.openxmlformats.org/drawingml/2006/main" xmlns:r="http://schemas.openxmlformats.org/officeDocument/2006/relationships" xmlns:p="http://schemas.openxmlformats.org/presentationml/2006/main">
   <p:cSld>
     <p:spTree>
@@ -8957,7 +7804,7 @@
 </p:sld>
 </file>
 
-<file path=ppt/slides/slide7.xml><?xml version="1.0" encoding="utf-8"?>
+<file path=ppt/slides/slide6.xml><?xml version="1.0" encoding="utf-8"?>
 <p:sld xmlns:a="http://schemas.openxmlformats.org/drawingml/2006/main" xmlns:r="http://schemas.openxmlformats.org/officeDocument/2006/relationships" xmlns:p="http://schemas.openxmlformats.org/presentationml/2006/main">
   <p:cSld>
     <p:spTree>
@@ -9275,7 +8122,7 @@
 </p:sld>
 </file>
 
-<file path=ppt/slides/slide8.xml><?xml version="1.0" encoding="utf-8"?>
+<file path=ppt/slides/slide7.xml><?xml version="1.0" encoding="utf-8"?>
 <p:sld xmlns:a="http://schemas.openxmlformats.org/drawingml/2006/main" xmlns:r="http://schemas.openxmlformats.org/officeDocument/2006/relationships" xmlns:p="http://schemas.openxmlformats.org/presentationml/2006/main">
   <p:cSld>
     <p:spTree>
@@ -9515,7 +8362,7 @@
 </p:sld>
 </file>
 
-<file path=ppt/slides/slide9.xml><?xml version="1.0" encoding="utf-8"?>
+<file path=ppt/slides/slide8.xml><?xml version="1.0" encoding="utf-8"?>
 <p:sld xmlns:a="http://schemas.openxmlformats.org/drawingml/2006/main" xmlns:r="http://schemas.openxmlformats.org/officeDocument/2006/relationships" xmlns:p="http://schemas.openxmlformats.org/presentationml/2006/main">
   <p:cSld>
     <p:spTree>
@@ -9690,6 +8537,364 @@
     <p:extLst>
       <p:ext uri="{BB962C8B-B14F-4D97-AF65-F5344CB8AC3E}">
         <p14:creationId xmlns:p14="http://schemas.microsoft.com/office/powerpoint/2010/main" val="3194468089"/>
+      </p:ext>
+    </p:extLst>
+  </p:cSld>
+  <p:clrMapOvr>
+    <a:masterClrMapping/>
+  </p:clrMapOvr>
+</p:sld>
+</file>
+
+<file path=ppt/slides/slide9.xml><?xml version="1.0" encoding="utf-8"?>
+<p:sld xmlns:a="http://schemas.openxmlformats.org/drawingml/2006/main" xmlns:r="http://schemas.openxmlformats.org/officeDocument/2006/relationships" xmlns:p="http://schemas.openxmlformats.org/presentationml/2006/main">
+  <p:cSld>
+    <p:spTree>
+      <p:nvGrpSpPr>
+        <p:cNvPr id="1" name="">
+          <a:extLst>
+            <a:ext uri="{FF2B5EF4-FFF2-40B4-BE49-F238E27FC236}">
+              <a16:creationId xmlns:a16="http://schemas.microsoft.com/office/drawing/2014/main" id="{62B008EB-38E0-474D-60A6-26EA8F71DB51}"/>
+            </a:ext>
+          </a:extLst>
+        </p:cNvPr>
+        <p:cNvGrpSpPr/>
+        <p:nvPr/>
+      </p:nvGrpSpPr>
+      <p:grpSpPr>
+        <a:xfrm>
+          <a:off x="0" y="0"/>
+          <a:ext cx="0" cy="0"/>
+          <a:chOff x="0" y="0"/>
+          <a:chExt cx="0" cy="0"/>
+        </a:xfrm>
+      </p:grpSpPr>
+      <p:sp>
+        <p:nvSpPr>
+          <p:cNvPr id="7" name="Retângulo: Cantos Arredondados 6">
+            <a:extLst>
+              <a:ext uri="{FF2B5EF4-FFF2-40B4-BE49-F238E27FC236}">
+                <a16:creationId xmlns:a16="http://schemas.microsoft.com/office/drawing/2014/main" id="{7AD6C141-DEC8-8565-1716-24689F1554EE}"/>
+              </a:ext>
+            </a:extLst>
+          </p:cNvPr>
+          <p:cNvSpPr/>
+          <p:nvPr/>
+        </p:nvSpPr>
+        <p:spPr>
+          <a:xfrm>
+            <a:off x="20094238" y="11281014"/>
+            <a:ext cx="8716591" cy="7533796"/>
+          </a:xfrm>
+          <a:prstGeom prst="roundRect">
+            <a:avLst>
+              <a:gd name="adj" fmla="val 3334"/>
+            </a:avLst>
+          </a:prstGeom>
+          <a:gradFill flip="none" rotWithShape="1">
+            <a:gsLst>
+              <a:gs pos="0">
+                <a:srgbClr val="05324B"/>
+              </a:gs>
+              <a:gs pos="62000">
+                <a:srgbClr val="032030"/>
+              </a:gs>
+              <a:gs pos="76000">
+                <a:srgbClr val="032030"/>
+              </a:gs>
+              <a:gs pos="100000">
+                <a:srgbClr val="032030"/>
+              </a:gs>
+            </a:gsLst>
+            <a:path path="circle">
+              <a:fillToRect l="50000" t="50000" r="50000" b="50000"/>
+            </a:path>
+            <a:tileRect/>
+          </a:gradFill>
+          <a:ln>
+            <a:noFill/>
+          </a:ln>
+        </p:spPr>
+        <p:style>
+          <a:lnRef idx="2">
+            <a:schemeClr val="accent1">
+              <a:shade val="50000"/>
+            </a:schemeClr>
+          </a:lnRef>
+          <a:fillRef idx="1">
+            <a:schemeClr val="accent1"/>
+          </a:fillRef>
+          <a:effectRef idx="0">
+            <a:schemeClr val="accent1"/>
+          </a:effectRef>
+          <a:fontRef idx="minor">
+            <a:schemeClr val="lt1"/>
+          </a:fontRef>
+        </p:style>
+        <p:txBody>
+          <a:bodyPr rtlCol="0" anchor="ctr"/>
+          <a:lstStyle/>
+          <a:p>
+            <a:pPr algn="ctr"/>
+            <a:endParaRPr lang="pt-BR" sz="2400"/>
+          </a:p>
+        </p:txBody>
+      </p:sp>
+      <p:sp>
+        <p:nvSpPr>
+          <p:cNvPr id="8" name="Retângulo: Cantos Arredondados 7">
+            <a:extLst>
+              <a:ext uri="{FF2B5EF4-FFF2-40B4-BE49-F238E27FC236}">
+                <a16:creationId xmlns:a16="http://schemas.microsoft.com/office/drawing/2014/main" id="{DF94C769-753C-DA72-7B3E-F8D5DA2C5086}"/>
+              </a:ext>
+            </a:extLst>
+          </p:cNvPr>
+          <p:cNvSpPr/>
+          <p:nvPr/>
+        </p:nvSpPr>
+        <p:spPr>
+          <a:xfrm>
+            <a:off x="20372372" y="13164930"/>
+            <a:ext cx="3890130" cy="1882981"/>
+          </a:xfrm>
+          <a:prstGeom prst="roundRect">
+            <a:avLst>
+              <a:gd name="adj" fmla="val 12781"/>
+            </a:avLst>
+          </a:prstGeom>
+          <a:gradFill flip="none" rotWithShape="1">
+            <a:gsLst>
+              <a:gs pos="0">
+                <a:srgbClr val="365160"/>
+              </a:gs>
+              <a:gs pos="62000">
+                <a:srgbClr val="032030"/>
+              </a:gs>
+              <a:gs pos="76000">
+                <a:srgbClr val="032030"/>
+              </a:gs>
+              <a:gs pos="100000">
+                <a:srgbClr val="032030"/>
+              </a:gs>
+            </a:gsLst>
+            <a:lin ang="2700000" scaled="1"/>
+            <a:tileRect/>
+          </a:gradFill>
+          <a:ln>
+            <a:noFill/>
+          </a:ln>
+          <a:effectLst>
+            <a:outerShdw blurRad="50800" dist="38100" dir="3300000" algn="t" rotWithShape="0">
+              <a:schemeClr val="bg1">
+                <a:alpha val="40000"/>
+              </a:schemeClr>
+            </a:outerShdw>
+          </a:effectLst>
+        </p:spPr>
+        <p:style>
+          <a:lnRef idx="2">
+            <a:schemeClr val="accent1">
+              <a:shade val="50000"/>
+            </a:schemeClr>
+          </a:lnRef>
+          <a:fillRef idx="1">
+            <a:schemeClr val="accent1"/>
+          </a:fillRef>
+          <a:effectRef idx="0">
+            <a:schemeClr val="accent1"/>
+          </a:effectRef>
+          <a:fontRef idx="minor">
+            <a:schemeClr val="lt1"/>
+          </a:fontRef>
+        </p:style>
+        <p:txBody>
+          <a:bodyPr rtlCol="0" anchor="ctr"/>
+          <a:lstStyle/>
+          <a:p>
+            <a:pPr algn="ctr"/>
+            <a:endParaRPr lang="pt-BR" sz="2400"/>
+          </a:p>
+        </p:txBody>
+      </p:sp>
+      <p:sp>
+        <p:nvSpPr>
+          <p:cNvPr id="11" name="Retângulo: Cantos Arredondados 10">
+            <a:extLst>
+              <a:ext uri="{FF2B5EF4-FFF2-40B4-BE49-F238E27FC236}">
+                <a16:creationId xmlns:a16="http://schemas.microsoft.com/office/drawing/2014/main" id="{538F2C06-13F9-4809-541D-DD1E667A76D2}"/>
+              </a:ext>
+            </a:extLst>
+          </p:cNvPr>
+          <p:cNvSpPr/>
+          <p:nvPr/>
+        </p:nvSpPr>
+        <p:spPr>
+          <a:xfrm>
+            <a:off x="20372372" y="11635685"/>
+            <a:ext cx="8160322" cy="1213647"/>
+          </a:xfrm>
+          <a:prstGeom prst="roundRect">
+            <a:avLst>
+              <a:gd name="adj" fmla="val 12781"/>
+            </a:avLst>
+          </a:prstGeom>
+          <a:gradFill flip="none" rotWithShape="1">
+            <a:gsLst>
+              <a:gs pos="0">
+                <a:srgbClr val="365160"/>
+              </a:gs>
+              <a:gs pos="62000">
+                <a:srgbClr val="032030"/>
+              </a:gs>
+              <a:gs pos="76000">
+                <a:srgbClr val="032030"/>
+              </a:gs>
+              <a:gs pos="100000">
+                <a:srgbClr val="032030"/>
+              </a:gs>
+            </a:gsLst>
+            <a:lin ang="2700000" scaled="1"/>
+            <a:tileRect/>
+          </a:gradFill>
+          <a:ln>
+            <a:noFill/>
+          </a:ln>
+          <a:effectLst>
+            <a:outerShdw blurRad="50800" dist="38100" dir="3300000" algn="t" rotWithShape="0">
+              <a:schemeClr val="bg1">
+                <a:alpha val="40000"/>
+              </a:schemeClr>
+            </a:outerShdw>
+          </a:effectLst>
+        </p:spPr>
+        <p:style>
+          <a:lnRef idx="2">
+            <a:schemeClr val="accent1">
+              <a:shade val="50000"/>
+            </a:schemeClr>
+          </a:lnRef>
+          <a:fillRef idx="1">
+            <a:schemeClr val="accent1"/>
+          </a:fillRef>
+          <a:effectRef idx="0">
+            <a:schemeClr val="accent1"/>
+          </a:effectRef>
+          <a:fontRef idx="minor">
+            <a:schemeClr val="lt1"/>
+          </a:fontRef>
+        </p:style>
+        <p:txBody>
+          <a:bodyPr rtlCol="0" anchor="ctr"/>
+          <a:lstStyle/>
+          <a:p>
+            <a:pPr algn="ctr"/>
+            <a:r>
+              <a:rPr lang="pt-BR" sz="4400" b="1" dirty="0">
+                <a:solidFill>
+                  <a:schemeClr val="bg1"/>
+                </a:solidFill>
+                <a:latin typeface="Din"/>
+              </a:rPr>
+              <a:t>Comportamento de </a:t>
+            </a:r>
+            <a:r>
+              <a:rPr lang="pt-BR" sz="4400" b="1" dirty="0" err="1">
+                <a:solidFill>
+                  <a:schemeClr val="bg1"/>
+                </a:solidFill>
+                <a:latin typeface="Din"/>
+              </a:rPr>
+              <a:t>Churn</a:t>
+            </a:r>
+            <a:endParaRPr lang="pt-BR" sz="4400" b="1" dirty="0">
+              <a:solidFill>
+                <a:schemeClr val="bg1"/>
+              </a:solidFill>
+              <a:latin typeface="Din"/>
+            </a:endParaRPr>
+          </a:p>
+        </p:txBody>
+      </p:sp>
+      <p:sp>
+        <p:nvSpPr>
+          <p:cNvPr id="14" name="Retângulo: Cantos Arredondados 13">
+            <a:extLst>
+              <a:ext uri="{FF2B5EF4-FFF2-40B4-BE49-F238E27FC236}">
+                <a16:creationId xmlns:a16="http://schemas.microsoft.com/office/drawing/2014/main" id="{43D63697-AF21-F0E5-4C28-20AF7486B378}"/>
+              </a:ext>
+            </a:extLst>
+          </p:cNvPr>
+          <p:cNvSpPr/>
+          <p:nvPr/>
+        </p:nvSpPr>
+        <p:spPr>
+          <a:xfrm>
+            <a:off x="24642564" y="13164930"/>
+            <a:ext cx="3890130" cy="1882981"/>
+          </a:xfrm>
+          <a:prstGeom prst="roundRect">
+            <a:avLst>
+              <a:gd name="adj" fmla="val 12781"/>
+            </a:avLst>
+          </a:prstGeom>
+          <a:gradFill flip="none" rotWithShape="1">
+            <a:gsLst>
+              <a:gs pos="0">
+                <a:srgbClr val="365160"/>
+              </a:gs>
+              <a:gs pos="62000">
+                <a:srgbClr val="032030"/>
+              </a:gs>
+              <a:gs pos="76000">
+                <a:srgbClr val="032030"/>
+              </a:gs>
+              <a:gs pos="100000">
+                <a:srgbClr val="032030"/>
+              </a:gs>
+            </a:gsLst>
+            <a:lin ang="2700000" scaled="1"/>
+            <a:tileRect/>
+          </a:gradFill>
+          <a:ln>
+            <a:noFill/>
+          </a:ln>
+          <a:effectLst>
+            <a:outerShdw blurRad="50800" dist="38100" dir="3300000" algn="t" rotWithShape="0">
+              <a:schemeClr val="bg1">
+                <a:alpha val="40000"/>
+              </a:schemeClr>
+            </a:outerShdw>
+          </a:effectLst>
+        </p:spPr>
+        <p:style>
+          <a:lnRef idx="2">
+            <a:schemeClr val="accent1">
+              <a:shade val="50000"/>
+            </a:schemeClr>
+          </a:lnRef>
+          <a:fillRef idx="1">
+            <a:schemeClr val="accent1"/>
+          </a:fillRef>
+          <a:effectRef idx="0">
+            <a:schemeClr val="accent1"/>
+          </a:effectRef>
+          <a:fontRef idx="minor">
+            <a:schemeClr val="lt1"/>
+          </a:fontRef>
+        </p:style>
+        <p:txBody>
+          <a:bodyPr rtlCol="0" anchor="ctr"/>
+          <a:lstStyle/>
+          <a:p>
+            <a:pPr algn="ctr"/>
+            <a:endParaRPr lang="pt-BR" sz="2400"/>
+          </a:p>
+        </p:txBody>
+      </p:sp>
+    </p:spTree>
+    <p:extLst>
+      <p:ext uri="{BB962C8B-B14F-4D97-AF65-F5344CB8AC3E}">
+        <p14:creationId xmlns:p14="http://schemas.microsoft.com/office/powerpoint/2010/main" val="3634488649"/>
       </p:ext>
     </p:extLst>
   </p:cSld>
@@ -9961,6 +9166,29 @@
 </file>
 
 <file path=customXml/item1.xml><?xml version="1.0" encoding="utf-8"?>
+<p:properties xmlns:p="http://schemas.microsoft.com/office/2006/metadata/properties" xmlns:xsi="http://www.w3.org/2001/XMLSchema-instance" xmlns:pc="http://schemas.microsoft.com/office/infopath/2007/PartnerControls">
+  <documentManagement>
+    <_ip_UnifiedCompliancePolicyUIAction xmlns="http://schemas.microsoft.com/sharepoint/v3" xsi:nil="true"/>
+    <lcf76f155ced4ddcb4097134ff3c332f xmlns="996f600e-0733-4526-a0fb-b18e680a05e7">
+      <Terms xmlns="http://schemas.microsoft.com/office/infopath/2007/PartnerControls"/>
+    </lcf76f155ced4ddcb4097134ff3c332f>
+    <TaxCatchAll xmlns="137de72a-d4ba-42bd-86fe-71b4bed90a39" xsi:nil="true"/>
+    <_ip_UnifiedCompliancePolicyProperties xmlns="http://schemas.microsoft.com/sharepoint/v3" xsi:nil="true"/>
+    <_Flow_SignoffStatus xmlns="996f600e-0733-4526-a0fb-b18e680a05e7" xsi:nil="true"/>
+  </documentManagement>
+</p:properties>
+</file>
+
+<file path=customXml/item2.xml><?xml version="1.0" encoding="utf-8"?>
+<?mso-contentType ?>
+<FormTemplates xmlns="http://schemas.microsoft.com/sharepoint/v3/contenttype/forms">
+  <Display>DocumentLibraryForm</Display>
+  <Edit>DocumentLibraryForm</Edit>
+  <New>DocumentLibraryForm</New>
+</FormTemplates>
+</file>
+
+<file path=customXml/item3.xml><?xml version="1.0" encoding="utf-8"?>
 <ct:contentTypeSchema xmlns:ct="http://schemas.microsoft.com/office/2006/metadata/contentType" xmlns:ma="http://schemas.microsoft.com/office/2006/metadata/properties/metaAttributes" ct:_="" ma:_="" ma:contentTypeName="Documento" ma:contentTypeID="0x010100BD8796E1EBEF0447B8A50267FB38BA07" ma:contentTypeVersion="21" ma:contentTypeDescription="Crie um novo documento." ma:contentTypeScope="" ma:versionID="51b69d7bf1e80634fb6243a48f7b967a">
   <xsd:schema xmlns:xsd="http://www.w3.org/2001/XMLSchema" xmlns:xs="http://www.w3.org/2001/XMLSchema" xmlns:p="http://schemas.microsoft.com/office/2006/metadata/properties" xmlns:ns1="http://schemas.microsoft.com/sharepoint/v3" xmlns:ns2="137de72a-d4ba-42bd-86fe-71b4bed90a39" xmlns:ns3="996f600e-0733-4526-a0fb-b18e680a05e7" targetNamespace="http://schemas.microsoft.com/office/2006/metadata/properties" ma:root="true" ma:fieldsID="ff2cafffd62144788c92268155a1b106" ns1:_="" ns2:_="" ns3:_="">
     <xsd:import namespace="http://schemas.microsoft.com/sharepoint/v3"/>
@@ -10238,30 +9466,33 @@
 </ct:contentTypeSchema>
 </file>
 
-<file path=customXml/item2.xml><?xml version="1.0" encoding="utf-8"?>
-<?mso-contentType ?>
-<FormTemplates xmlns="http://schemas.microsoft.com/sharepoint/v3/contenttype/forms">
-  <Display>DocumentLibraryForm</Display>
-  <Edit>DocumentLibraryForm</Edit>
-  <New>DocumentLibraryForm</New>
-</FormTemplates>
+<file path=customXml/itemProps1.xml><?xml version="1.0" encoding="utf-8"?>
+<ds:datastoreItem xmlns:ds="http://schemas.openxmlformats.org/officeDocument/2006/customXml" ds:itemID="{BCFDE38A-F306-4C4A-AFC1-208A8755E640}">
+  <ds:schemaRefs>
+    <ds:schemaRef ds:uri="http://purl.org/dc/elements/1.1/"/>
+    <ds:schemaRef ds:uri="http://schemas.microsoft.com/sharepoint/v3"/>
+    <ds:schemaRef ds:uri="http://schemas.openxmlformats.org/package/2006/metadata/core-properties"/>
+    <ds:schemaRef ds:uri="http://purl.org/dc/terms/"/>
+    <ds:schemaRef ds:uri="http://schemas.microsoft.com/office/infopath/2007/PartnerControls"/>
+    <ds:schemaRef ds:uri="http://schemas.microsoft.com/office/2006/documentManagement/types"/>
+    <ds:schemaRef ds:uri="996f600e-0733-4526-a0fb-b18e680a05e7"/>
+    <ds:schemaRef ds:uri="http://schemas.microsoft.com/office/2006/metadata/properties"/>
+    <ds:schemaRef ds:uri="137de72a-d4ba-42bd-86fe-71b4bed90a39"/>
+    <ds:schemaRef ds:uri="http://www.w3.org/XML/1998/namespace"/>
+    <ds:schemaRef ds:uri="http://purl.org/dc/dcmitype/"/>
+  </ds:schemaRefs>
+</ds:datastoreItem>
 </file>
 
-<file path=customXml/item3.xml><?xml version="1.0" encoding="utf-8"?>
-<p:properties xmlns:p="http://schemas.microsoft.com/office/2006/metadata/properties" xmlns:xsi="http://www.w3.org/2001/XMLSchema-instance" xmlns:pc="http://schemas.microsoft.com/office/infopath/2007/PartnerControls">
-  <documentManagement>
-    <_ip_UnifiedCompliancePolicyUIAction xmlns="http://schemas.microsoft.com/sharepoint/v3" xsi:nil="true"/>
-    <lcf76f155ced4ddcb4097134ff3c332f xmlns="996f600e-0733-4526-a0fb-b18e680a05e7">
-      <Terms xmlns="http://schemas.microsoft.com/office/infopath/2007/PartnerControls"/>
-    </lcf76f155ced4ddcb4097134ff3c332f>
-    <TaxCatchAll xmlns="137de72a-d4ba-42bd-86fe-71b4bed90a39" xsi:nil="true"/>
-    <_ip_UnifiedCompliancePolicyProperties xmlns="http://schemas.microsoft.com/sharepoint/v3" xsi:nil="true"/>
-    <_Flow_SignoffStatus xmlns="996f600e-0733-4526-a0fb-b18e680a05e7" xsi:nil="true"/>
-  </documentManagement>
-</p:properties>
+<file path=customXml/itemProps2.xml><?xml version="1.0" encoding="utf-8"?>
+<ds:datastoreItem xmlns:ds="http://schemas.openxmlformats.org/officeDocument/2006/customXml" ds:itemID="{AAE51230-9E4E-4FDB-9D86-2789E42C6788}">
+  <ds:schemaRefs>
+    <ds:schemaRef ds:uri="http://schemas.microsoft.com/sharepoint/v3/contenttype/forms"/>
+  </ds:schemaRefs>
+</ds:datastoreItem>
 </file>
 
-<file path=customXml/itemProps1.xml><?xml version="1.0" encoding="utf-8"?>
+<file path=customXml/itemProps3.xml><?xml version="1.0" encoding="utf-8"?>
 <ds:datastoreItem xmlns:ds="http://schemas.openxmlformats.org/officeDocument/2006/customXml" ds:itemID="{56FEFCE5-4A7D-48BD-A3A8-BA9D11A8CFE8}">
   <ds:schemaRefs>
     <ds:schemaRef ds:uri="http://schemas.microsoft.com/office/2006/metadata/contentType"/>
@@ -10279,30 +9510,4 @@
     <ds:schemaRef ds:uri="http://schemas.microsoft.com/internal/obd"/>
   </ds:schemaRefs>
 </ds:datastoreItem>
-</file>
-
-<file path=customXml/itemProps2.xml><?xml version="1.0" encoding="utf-8"?>
-<ds:datastoreItem xmlns:ds="http://schemas.openxmlformats.org/officeDocument/2006/customXml" ds:itemID="{AAE51230-9E4E-4FDB-9D86-2789E42C6788}">
-  <ds:schemaRefs>
-    <ds:schemaRef ds:uri="http://schemas.microsoft.com/sharepoint/v3/contenttype/forms"/>
-  </ds:schemaRefs>
-</ds:datastoreItem>
-</file>
-
-<file path=customXml/itemProps3.xml><?xml version="1.0" encoding="utf-8"?>
-<ds:datastoreItem xmlns:ds="http://schemas.openxmlformats.org/officeDocument/2006/customXml" ds:itemID="{BCFDE38A-F306-4C4A-AFC1-208A8755E640}">
-  <ds:schemaRefs>
-    <ds:schemaRef ds:uri="http://purl.org/dc/elements/1.1/"/>
-    <ds:schemaRef ds:uri="http://schemas.microsoft.com/sharepoint/v3"/>
-    <ds:schemaRef ds:uri="http://schemas.openxmlformats.org/package/2006/metadata/core-properties"/>
-    <ds:schemaRef ds:uri="http://purl.org/dc/terms/"/>
-    <ds:schemaRef ds:uri="http://schemas.microsoft.com/office/infopath/2007/PartnerControls"/>
-    <ds:schemaRef ds:uri="http://schemas.microsoft.com/office/2006/documentManagement/types"/>
-    <ds:schemaRef ds:uri="996f600e-0733-4526-a0fb-b18e680a05e7"/>
-    <ds:schemaRef ds:uri="http://schemas.microsoft.com/office/2006/metadata/properties"/>
-    <ds:schemaRef ds:uri="137de72a-d4ba-42bd-86fe-71b4bed90a39"/>
-    <ds:schemaRef ds:uri="http://www.w3.org/XML/1998/namespace"/>
-    <ds:schemaRef ds:uri="http://purl.org/dc/dcmitype/"/>
-  </ds:schemaRefs>
-</ds:datastoreItem>
 </file>
</xml_diff>

<commit_message>
Criado aba análise de Canais e Regiões
Criado layout ppt, criado medidas complementares, realizado concatenação entre canal e regiao para criação de score, inserido gráfico heatmap, Matriz BCG, gráfico de dispersão, filtro suspenso, cards de receita, margem e crescimento YoY
</commit_message>
<xml_diff>
--- a/Background - Fundo Para BI.pptx
+++ b/Background - Fundo Para BI.pptx
@@ -5548,8 +5548,8 @@
         </p:nvSpPr>
         <p:spPr>
           <a:xfrm>
-            <a:off x="18698354" y="12748980"/>
-            <a:ext cx="7387446" cy="3037120"/>
+            <a:off x="18698354" y="11081482"/>
+            <a:ext cx="7387446" cy="7890750"/>
           </a:xfrm>
           <a:prstGeom prst="roundRect">
             <a:avLst>
@@ -5600,198 +5600,6 @@
           </a:p>
         </p:txBody>
       </p:sp>
-      <p:sp>
-        <p:nvSpPr>
-          <p:cNvPr id="62" name="Retângulo: Cantos Arredondados 61">
-            <a:extLst>
-              <a:ext uri="{FF2B5EF4-FFF2-40B4-BE49-F238E27FC236}">
-                <a16:creationId xmlns:a16="http://schemas.microsoft.com/office/drawing/2014/main" id="{8C763677-5DA4-B22F-217A-52AB0C379F53}"/>
-              </a:ext>
-            </a:extLst>
-          </p:cNvPr>
-          <p:cNvSpPr/>
-          <p:nvPr/>
-        </p:nvSpPr>
-        <p:spPr>
-          <a:xfrm>
-            <a:off x="20836836" y="11068944"/>
-            <a:ext cx="2573924" cy="1519713"/>
-          </a:xfrm>
-          <a:prstGeom prst="roundRect">
-            <a:avLst/>
-          </a:prstGeom>
-          <a:solidFill>
-            <a:schemeClr val="bg1"/>
-          </a:solidFill>
-          <a:ln>
-            <a:noFill/>
-          </a:ln>
-          <a:effectLst>
-            <a:outerShdw blurRad="50800" dist="38100" dir="5400000" algn="t" rotWithShape="0">
-              <a:srgbClr val="05324B">
-                <a:alpha val="40000"/>
-              </a:srgbClr>
-            </a:outerShdw>
-          </a:effectLst>
-        </p:spPr>
-        <p:style>
-          <a:lnRef idx="2">
-            <a:schemeClr val="accent1">
-              <a:shade val="50000"/>
-            </a:schemeClr>
-          </a:lnRef>
-          <a:fillRef idx="1">
-            <a:schemeClr val="accent1"/>
-          </a:fillRef>
-          <a:effectRef idx="0">
-            <a:schemeClr val="accent1"/>
-          </a:effectRef>
-          <a:fontRef idx="minor">
-            <a:schemeClr val="lt1"/>
-          </a:fontRef>
-        </p:style>
-        <p:txBody>
-          <a:bodyPr rtlCol="0" anchor="ctr"/>
-          <a:lstStyle/>
-          <a:p>
-            <a:pPr algn="ctr"/>
-            <a:endParaRPr lang="pt-BR" sz="2400">
-              <a:solidFill>
-                <a:prstClr val="white"/>
-              </a:solidFill>
-              <a:latin typeface="Calibri" panose="020F0502020204030204"/>
-            </a:endParaRPr>
-          </a:p>
-        </p:txBody>
-      </p:sp>
-      <p:sp>
-        <p:nvSpPr>
-          <p:cNvPr id="63" name="Retângulo: Cantos Arredondados 62">
-            <a:extLst>
-              <a:ext uri="{FF2B5EF4-FFF2-40B4-BE49-F238E27FC236}">
-                <a16:creationId xmlns:a16="http://schemas.microsoft.com/office/drawing/2014/main" id="{9DABE012-C992-6CC0-0D9E-FF292C66EC94}"/>
-              </a:ext>
-            </a:extLst>
-          </p:cNvPr>
-          <p:cNvSpPr/>
-          <p:nvPr/>
-        </p:nvSpPr>
-        <p:spPr>
-          <a:xfrm>
-            <a:off x="23526055" y="11068944"/>
-            <a:ext cx="2573924" cy="1519713"/>
-          </a:xfrm>
-          <a:prstGeom prst="roundRect">
-            <a:avLst/>
-          </a:prstGeom>
-          <a:solidFill>
-            <a:schemeClr val="bg1"/>
-          </a:solidFill>
-          <a:ln>
-            <a:noFill/>
-          </a:ln>
-          <a:effectLst>
-            <a:outerShdw blurRad="50800" dist="38100" dir="5400000" algn="t" rotWithShape="0">
-              <a:srgbClr val="05324B">
-                <a:alpha val="40000"/>
-              </a:srgbClr>
-            </a:outerShdw>
-          </a:effectLst>
-        </p:spPr>
-        <p:style>
-          <a:lnRef idx="2">
-            <a:schemeClr val="accent1">
-              <a:shade val="50000"/>
-            </a:schemeClr>
-          </a:lnRef>
-          <a:fillRef idx="1">
-            <a:schemeClr val="accent1"/>
-          </a:fillRef>
-          <a:effectRef idx="0">
-            <a:schemeClr val="accent1"/>
-          </a:effectRef>
-          <a:fontRef idx="minor">
-            <a:schemeClr val="lt1"/>
-          </a:fontRef>
-        </p:style>
-        <p:txBody>
-          <a:bodyPr rtlCol="0" anchor="ctr"/>
-          <a:lstStyle/>
-          <a:p>
-            <a:pPr algn="ctr"/>
-            <a:endParaRPr lang="pt-BR" sz="2400">
-              <a:solidFill>
-                <a:prstClr val="white"/>
-              </a:solidFill>
-              <a:latin typeface="Calibri" panose="020F0502020204030204"/>
-            </a:endParaRPr>
-          </a:p>
-        </p:txBody>
-      </p:sp>
-      <p:sp>
-        <p:nvSpPr>
-          <p:cNvPr id="64" name="Retângulo: Cantos Arredondados 63">
-            <a:extLst>
-              <a:ext uri="{FF2B5EF4-FFF2-40B4-BE49-F238E27FC236}">
-                <a16:creationId xmlns:a16="http://schemas.microsoft.com/office/drawing/2014/main" id="{72AF9DCA-D8E4-C2EF-2A3D-F2D2208DEFC4}"/>
-              </a:ext>
-            </a:extLst>
-          </p:cNvPr>
-          <p:cNvSpPr/>
-          <p:nvPr/>
-        </p:nvSpPr>
-        <p:spPr>
-          <a:xfrm>
-            <a:off x="26215274" y="11068944"/>
-            <a:ext cx="2573924" cy="1519713"/>
-          </a:xfrm>
-          <a:prstGeom prst="roundRect">
-            <a:avLst/>
-          </a:prstGeom>
-          <a:solidFill>
-            <a:schemeClr val="bg1"/>
-          </a:solidFill>
-          <a:ln>
-            <a:noFill/>
-          </a:ln>
-          <a:effectLst>
-            <a:outerShdw blurRad="50800" dist="38100" dir="5400000" algn="t" rotWithShape="0">
-              <a:srgbClr val="05324B">
-                <a:alpha val="40000"/>
-              </a:srgbClr>
-            </a:outerShdw>
-          </a:effectLst>
-        </p:spPr>
-        <p:style>
-          <a:lnRef idx="2">
-            <a:schemeClr val="accent1">
-              <a:shade val="50000"/>
-            </a:schemeClr>
-          </a:lnRef>
-          <a:fillRef idx="1">
-            <a:schemeClr val="accent1"/>
-          </a:fillRef>
-          <a:effectRef idx="0">
-            <a:schemeClr val="accent1"/>
-          </a:effectRef>
-          <a:fontRef idx="minor">
-            <a:schemeClr val="lt1"/>
-          </a:fontRef>
-        </p:style>
-        <p:txBody>
-          <a:bodyPr rtlCol="0" anchor="ctr"/>
-          <a:lstStyle/>
-          <a:p>
-            <a:pPr algn="ctr"/>
-            <a:endParaRPr lang="pt-BR" sz="2400">
-              <a:solidFill>
-                <a:prstClr val="white"/>
-              </a:solidFill>
-              <a:latin typeface="Calibri" panose="020F0502020204030204"/>
-            </a:endParaRPr>
-          </a:p>
-        </p:txBody>
-      </p:sp>
       <p:pic>
         <p:nvPicPr>
           <p:cNvPr id="66" name="Imagem 65" descr="Ícone&#10;&#10;O conteúdo gerado por IA pode estar incorreto.">
@@ -5936,8 +5744,8 @@
         </p:nvSpPr>
         <p:spPr>
           <a:xfrm>
-            <a:off x="18712532" y="15935112"/>
-            <a:ext cx="14890187" cy="3037120"/>
+            <a:off x="26215273" y="15935112"/>
+            <a:ext cx="7387446" cy="3037120"/>
           </a:xfrm>
           <a:prstGeom prst="roundRect">
             <a:avLst>
@@ -6111,8 +5919,136 @@
         </p:nvSpPr>
         <p:spPr>
           <a:xfrm>
-            <a:off x="28904493" y="11068944"/>
-            <a:ext cx="2573924" cy="1519713"/>
+            <a:off x="31226719" y="11068944"/>
+            <a:ext cx="2376000" cy="1519713"/>
+          </a:xfrm>
+          <a:prstGeom prst="roundRect">
+            <a:avLst/>
+          </a:prstGeom>
+          <a:solidFill>
+            <a:schemeClr val="bg1"/>
+          </a:solidFill>
+          <a:ln>
+            <a:noFill/>
+          </a:ln>
+          <a:effectLst>
+            <a:outerShdw blurRad="50800" dist="38100" dir="5400000" algn="t" rotWithShape="0">
+              <a:srgbClr val="05324B">
+                <a:alpha val="40000"/>
+              </a:srgbClr>
+            </a:outerShdw>
+          </a:effectLst>
+        </p:spPr>
+        <p:style>
+          <a:lnRef idx="2">
+            <a:schemeClr val="accent1">
+              <a:shade val="50000"/>
+            </a:schemeClr>
+          </a:lnRef>
+          <a:fillRef idx="1">
+            <a:schemeClr val="accent1"/>
+          </a:fillRef>
+          <a:effectRef idx="0">
+            <a:schemeClr val="accent1"/>
+          </a:effectRef>
+          <a:fontRef idx="minor">
+            <a:schemeClr val="lt1"/>
+          </a:fontRef>
+        </p:style>
+        <p:txBody>
+          <a:bodyPr rtlCol="0" anchor="ctr"/>
+          <a:lstStyle/>
+          <a:p>
+            <a:pPr algn="ctr"/>
+            <a:endParaRPr lang="pt-BR" sz="2400">
+              <a:solidFill>
+                <a:prstClr val="white"/>
+              </a:solidFill>
+              <a:latin typeface="Calibri" panose="020F0502020204030204"/>
+            </a:endParaRPr>
+          </a:p>
+        </p:txBody>
+      </p:sp>
+      <p:sp>
+        <p:nvSpPr>
+          <p:cNvPr id="7" name="Retângulo: Cantos Arredondados 6">
+            <a:extLst>
+              <a:ext uri="{FF2B5EF4-FFF2-40B4-BE49-F238E27FC236}">
+                <a16:creationId xmlns:a16="http://schemas.microsoft.com/office/drawing/2014/main" id="{C4748862-73B5-3616-6E54-5CDF8E180BAC}"/>
+              </a:ext>
+            </a:extLst>
+          </p:cNvPr>
+          <p:cNvSpPr/>
+          <p:nvPr/>
+        </p:nvSpPr>
+        <p:spPr>
+          <a:xfrm>
+            <a:off x="28720996" y="11081482"/>
+            <a:ext cx="2376000" cy="1519713"/>
+          </a:xfrm>
+          <a:prstGeom prst="roundRect">
+            <a:avLst/>
+          </a:prstGeom>
+          <a:solidFill>
+            <a:schemeClr val="bg1"/>
+          </a:solidFill>
+          <a:ln>
+            <a:noFill/>
+          </a:ln>
+          <a:effectLst>
+            <a:outerShdw blurRad="50800" dist="38100" dir="5400000" algn="t" rotWithShape="0">
+              <a:srgbClr val="05324B">
+                <a:alpha val="40000"/>
+              </a:srgbClr>
+            </a:outerShdw>
+          </a:effectLst>
+        </p:spPr>
+        <p:style>
+          <a:lnRef idx="2">
+            <a:schemeClr val="accent1">
+              <a:shade val="50000"/>
+            </a:schemeClr>
+          </a:lnRef>
+          <a:fillRef idx="1">
+            <a:schemeClr val="accent1"/>
+          </a:fillRef>
+          <a:effectRef idx="0">
+            <a:schemeClr val="accent1"/>
+          </a:effectRef>
+          <a:fontRef idx="minor">
+            <a:schemeClr val="lt1"/>
+          </a:fontRef>
+        </p:style>
+        <p:txBody>
+          <a:bodyPr rtlCol="0" anchor="ctr"/>
+          <a:lstStyle/>
+          <a:p>
+            <a:pPr algn="ctr"/>
+            <a:endParaRPr lang="pt-BR" sz="2400">
+              <a:solidFill>
+                <a:prstClr val="white"/>
+              </a:solidFill>
+              <a:latin typeface="Calibri" panose="020F0502020204030204"/>
+            </a:endParaRPr>
+          </a:p>
+        </p:txBody>
+      </p:sp>
+      <p:sp>
+        <p:nvSpPr>
+          <p:cNvPr id="9" name="Retângulo: Cantos Arredondados 8">
+            <a:extLst>
+              <a:ext uri="{FF2B5EF4-FFF2-40B4-BE49-F238E27FC236}">
+                <a16:creationId xmlns:a16="http://schemas.microsoft.com/office/drawing/2014/main" id="{425F0E46-250C-6F37-9D3D-8933275ED64F}"/>
+              </a:ext>
+            </a:extLst>
+          </p:cNvPr>
+          <p:cNvSpPr/>
+          <p:nvPr/>
+        </p:nvSpPr>
+        <p:spPr>
+          <a:xfrm>
+            <a:off x="26215273" y="11068944"/>
+            <a:ext cx="2376000" cy="1519713"/>
           </a:xfrm>
           <a:prstGeom prst="roundRect">
             <a:avLst/>

</xml_diff>